<commit_message>
Data cleanup and more outputs, new iteration of powerpoint
</commit_message>
<xml_diff>
--- a/IT388_ParallelNaiveBayes_Final.pptx
+++ b/IT388_ParallelNaiveBayes_Final.pptx
@@ -132,6 +132,582 @@
     </p:ext>
   </p:extLst>
 </p:presentation>
+</file>
+
+<file path=ppt/revisionInfo.xml><?xml version="1.0" encoding="utf-8"?>
+<p1510:revInfo xmlns:a="http://schemas.openxmlformats.org/drawingml/2006/main" xmlns:r="http://schemas.openxmlformats.org/officeDocument/2006/relationships" xmlns:p1510="http://schemas.microsoft.com/office/powerpoint/2015/10/main">
+  <p1510:revLst>
+    <p1510:client id="{DA307683-F528-4545-98BE-6884735B25C7}" v="12" dt="2026-04-25T16:12:58.084"/>
+  </p1510:revLst>
+</p1510:revInfo>
+</file>
+
+<file path=ppt/changesInfos/changesInfo1.xml><?xml version="1.0" encoding="utf-8"?>
+<pc:chgInfo xmlns:a="http://schemas.openxmlformats.org/drawingml/2006/main" xmlns:r="http://schemas.openxmlformats.org/officeDocument/2006/relationships" xmlns:ac="http://schemas.microsoft.com/office/drawing/2013/main/command" xmlns:pc="http://schemas.microsoft.com/office/powerpoint/2013/main/command">
+  <pc:docChgLst>
+    <pc:chgData name="Justin Hoffman" userId="40d7c2b8f9dba042" providerId="LiveId" clId="{98AE922D-438C-4FBD-AB6F-EAC5EAC34870}"/>
+    <pc:docChg chg="undo custSel modSld">
+      <pc:chgData name="Justin Hoffman" userId="40d7c2b8f9dba042" providerId="LiveId" clId="{98AE922D-438C-4FBD-AB6F-EAC5EAC34870}" dt="2026-04-25T16:13:00.018" v="1132" actId="20577"/>
+      <pc:docMkLst>
+        <pc:docMk/>
+      </pc:docMkLst>
+      <pc:sldChg chg="modSp mod">
+        <pc:chgData name="Justin Hoffman" userId="40d7c2b8f9dba042" providerId="LiveId" clId="{98AE922D-438C-4FBD-AB6F-EAC5EAC34870}" dt="2026-04-25T06:05:05.540" v="564" actId="255"/>
+        <pc:sldMkLst>
+          <pc:docMk/>
+          <pc:sldMk cId="0" sldId="256"/>
+        </pc:sldMkLst>
+        <pc:spChg chg="mod">
+          <ac:chgData name="Justin Hoffman" userId="40d7c2b8f9dba042" providerId="LiveId" clId="{98AE922D-438C-4FBD-AB6F-EAC5EAC34870}" dt="2026-04-25T06:04:17.782" v="561" actId="255"/>
+          <ac:spMkLst>
+            <pc:docMk/>
+            <pc:sldMk cId="0" sldId="256"/>
+            <ac:spMk id="4" creationId="{00000000-0000-0000-0000-000000000000}"/>
+          </ac:spMkLst>
+        </pc:spChg>
+        <pc:spChg chg="mod">
+          <ac:chgData name="Justin Hoffman" userId="40d7c2b8f9dba042" providerId="LiveId" clId="{98AE922D-438C-4FBD-AB6F-EAC5EAC34870}" dt="2026-04-25T06:04:27.980" v="562" actId="255"/>
+          <ac:spMkLst>
+            <pc:docMk/>
+            <pc:sldMk cId="0" sldId="256"/>
+            <ac:spMk id="7" creationId="{00000000-0000-0000-0000-000000000000}"/>
+          </ac:spMkLst>
+        </pc:spChg>
+        <pc:spChg chg="mod">
+          <ac:chgData name="Justin Hoffman" userId="40d7c2b8f9dba042" providerId="LiveId" clId="{98AE922D-438C-4FBD-AB6F-EAC5EAC34870}" dt="2026-04-25T06:04:53.459" v="563" actId="255"/>
+          <ac:spMkLst>
+            <pc:docMk/>
+            <pc:sldMk cId="0" sldId="256"/>
+            <ac:spMk id="10" creationId="{00000000-0000-0000-0000-000000000000}"/>
+          </ac:spMkLst>
+        </pc:spChg>
+        <pc:spChg chg="mod">
+          <ac:chgData name="Justin Hoffman" userId="40d7c2b8f9dba042" providerId="LiveId" clId="{98AE922D-438C-4FBD-AB6F-EAC5EAC34870}" dt="2026-04-25T06:05:05.540" v="564" actId="255"/>
+          <ac:spMkLst>
+            <pc:docMk/>
+            <pc:sldMk cId="0" sldId="256"/>
+            <ac:spMk id="13" creationId="{00000000-0000-0000-0000-000000000000}"/>
+          </ac:spMkLst>
+        </pc:spChg>
+      </pc:sldChg>
+      <pc:sldChg chg="modSp mod">
+        <pc:chgData name="Justin Hoffman" userId="40d7c2b8f9dba042" providerId="LiveId" clId="{98AE922D-438C-4FBD-AB6F-EAC5EAC34870}" dt="2026-04-25T03:16:45.152" v="3" actId="20577"/>
+        <pc:sldMkLst>
+          <pc:docMk/>
+          <pc:sldMk cId="0" sldId="257"/>
+        </pc:sldMkLst>
+        <pc:spChg chg="mod">
+          <ac:chgData name="Justin Hoffman" userId="40d7c2b8f9dba042" providerId="LiveId" clId="{98AE922D-438C-4FBD-AB6F-EAC5EAC34870}" dt="2026-04-25T03:16:45.152" v="3" actId="20577"/>
+          <ac:spMkLst>
+            <pc:docMk/>
+            <pc:sldMk cId="0" sldId="257"/>
+            <ac:spMk id="4" creationId="{00000000-0000-0000-0000-000000000000}"/>
+          </ac:spMkLst>
+        </pc:spChg>
+        <pc:spChg chg="mod">
+          <ac:chgData name="Justin Hoffman" userId="40d7c2b8f9dba042" providerId="LiveId" clId="{98AE922D-438C-4FBD-AB6F-EAC5EAC34870}" dt="2026-04-25T03:15:35.548" v="1" actId="2710"/>
+          <ac:spMkLst>
+            <pc:docMk/>
+            <pc:sldMk cId="0" sldId="257"/>
+            <ac:spMk id="8" creationId="{00000000-0000-0000-0000-000000000000}"/>
+          </ac:spMkLst>
+        </pc:spChg>
+      </pc:sldChg>
+      <pc:sldChg chg="modSp mod">
+        <pc:chgData name="Justin Hoffman" userId="40d7c2b8f9dba042" providerId="LiveId" clId="{98AE922D-438C-4FBD-AB6F-EAC5EAC34870}" dt="2026-04-25T03:20:35.814" v="90" actId="20577"/>
+        <pc:sldMkLst>
+          <pc:docMk/>
+          <pc:sldMk cId="0" sldId="261"/>
+        </pc:sldMkLst>
+        <pc:spChg chg="mod">
+          <ac:chgData name="Justin Hoffman" userId="40d7c2b8f9dba042" providerId="LiveId" clId="{98AE922D-438C-4FBD-AB6F-EAC5EAC34870}" dt="2026-04-25T03:20:35.814" v="90" actId="20577"/>
+          <ac:spMkLst>
+            <pc:docMk/>
+            <pc:sldMk cId="0" sldId="261"/>
+            <ac:spMk id="5" creationId="{00000000-0000-0000-0000-000000000000}"/>
+          </ac:spMkLst>
+        </pc:spChg>
+        <pc:spChg chg="mod">
+          <ac:chgData name="Justin Hoffman" userId="40d7c2b8f9dba042" providerId="LiveId" clId="{98AE922D-438C-4FBD-AB6F-EAC5EAC34870}" dt="2026-04-25T03:19:31.356" v="66" actId="20577"/>
+          <ac:spMkLst>
+            <pc:docMk/>
+            <pc:sldMk cId="0" sldId="261"/>
+            <ac:spMk id="7" creationId="{00000000-0000-0000-0000-000000000000}"/>
+          </ac:spMkLst>
+        </pc:spChg>
+        <pc:spChg chg="mod">
+          <ac:chgData name="Justin Hoffman" userId="40d7c2b8f9dba042" providerId="LiveId" clId="{98AE922D-438C-4FBD-AB6F-EAC5EAC34870}" dt="2026-04-25T03:18:17.816" v="24" actId="20577"/>
+          <ac:spMkLst>
+            <pc:docMk/>
+            <pc:sldMk cId="0" sldId="261"/>
+            <ac:spMk id="9" creationId="{00000000-0000-0000-0000-000000000000}"/>
+          </ac:spMkLst>
+        </pc:spChg>
+        <pc:spChg chg="mod">
+          <ac:chgData name="Justin Hoffman" userId="40d7c2b8f9dba042" providerId="LiveId" clId="{98AE922D-438C-4FBD-AB6F-EAC5EAC34870}" dt="2026-04-25T03:17:34.938" v="22" actId="20577"/>
+          <ac:spMkLst>
+            <pc:docMk/>
+            <pc:sldMk cId="0" sldId="261"/>
+            <ac:spMk id="11" creationId="{00000000-0000-0000-0000-000000000000}"/>
+          </ac:spMkLst>
+        </pc:spChg>
+        <pc:spChg chg="mod">
+          <ac:chgData name="Justin Hoffman" userId="40d7c2b8f9dba042" providerId="LiveId" clId="{98AE922D-438C-4FBD-AB6F-EAC5EAC34870}" dt="2026-04-25T03:18:44.558" v="51" actId="20577"/>
+          <ac:spMkLst>
+            <pc:docMk/>
+            <pc:sldMk cId="0" sldId="261"/>
+            <ac:spMk id="12" creationId="{00000000-0000-0000-0000-000000000000}"/>
+          </ac:spMkLst>
+        </pc:spChg>
+        <pc:spChg chg="mod">
+          <ac:chgData name="Justin Hoffman" userId="40d7c2b8f9dba042" providerId="LiveId" clId="{98AE922D-438C-4FBD-AB6F-EAC5EAC34870}" dt="2026-04-25T03:19:18.615" v="63" actId="255"/>
+          <ac:spMkLst>
+            <pc:docMk/>
+            <pc:sldMk cId="0" sldId="261"/>
+            <ac:spMk id="15" creationId="{00000000-0000-0000-0000-000000000000}"/>
+          </ac:spMkLst>
+        </pc:spChg>
+      </pc:sldChg>
+      <pc:sldChg chg="addSp delSp modSp mod">
+        <pc:chgData name="Justin Hoffman" userId="40d7c2b8f9dba042" providerId="LiveId" clId="{98AE922D-438C-4FBD-AB6F-EAC5EAC34870}" dt="2026-04-25T03:22:11.851" v="178" actId="1035"/>
+        <pc:sldMkLst>
+          <pc:docMk/>
+          <pc:sldMk cId="0" sldId="262"/>
+        </pc:sldMkLst>
+        <pc:spChg chg="add del mod">
+          <ac:chgData name="Justin Hoffman" userId="40d7c2b8f9dba042" providerId="LiveId" clId="{98AE922D-438C-4FBD-AB6F-EAC5EAC34870}" dt="2026-04-25T03:21:06.043" v="129" actId="20577"/>
+          <ac:spMkLst>
+            <pc:docMk/>
+            <pc:sldMk cId="0" sldId="262"/>
+            <ac:spMk id="7" creationId="{00000000-0000-0000-0000-000000000000}"/>
+          </ac:spMkLst>
+        </pc:spChg>
+        <pc:spChg chg="mod">
+          <ac:chgData name="Justin Hoffman" userId="40d7c2b8f9dba042" providerId="LiveId" clId="{98AE922D-438C-4FBD-AB6F-EAC5EAC34870}" dt="2026-04-25T03:21:54.748" v="165" actId="14100"/>
+          <ac:spMkLst>
+            <pc:docMk/>
+            <pc:sldMk cId="0" sldId="262"/>
+            <ac:spMk id="8" creationId="{00000000-0000-0000-0000-000000000000}"/>
+          </ac:spMkLst>
+        </pc:spChg>
+        <pc:spChg chg="mod">
+          <ac:chgData name="Justin Hoffman" userId="40d7c2b8f9dba042" providerId="LiveId" clId="{98AE922D-438C-4FBD-AB6F-EAC5EAC34870}" dt="2026-04-25T03:22:11.851" v="178" actId="1035"/>
+          <ac:spMkLst>
+            <pc:docMk/>
+            <pc:sldMk cId="0" sldId="262"/>
+            <ac:spMk id="10" creationId="{00000000-0000-0000-0000-000000000000}"/>
+          </ac:spMkLst>
+        </pc:spChg>
+        <pc:spChg chg="mod">
+          <ac:chgData name="Justin Hoffman" userId="40d7c2b8f9dba042" providerId="LiveId" clId="{98AE922D-438C-4FBD-AB6F-EAC5EAC34870}" dt="2026-04-25T03:22:02.854" v="170" actId="1036"/>
+          <ac:spMkLst>
+            <pc:docMk/>
+            <pc:sldMk cId="0" sldId="262"/>
+            <ac:spMk id="11" creationId="{00000000-0000-0000-0000-000000000000}"/>
+          </ac:spMkLst>
+        </pc:spChg>
+        <pc:spChg chg="mod">
+          <ac:chgData name="Justin Hoffman" userId="40d7c2b8f9dba042" providerId="LiveId" clId="{98AE922D-438C-4FBD-AB6F-EAC5EAC34870}" dt="2026-04-25T03:22:02.854" v="170" actId="1036"/>
+          <ac:spMkLst>
+            <pc:docMk/>
+            <pc:sldMk cId="0" sldId="262"/>
+            <ac:spMk id="12" creationId="{00000000-0000-0000-0000-000000000000}"/>
+          </ac:spMkLst>
+        </pc:spChg>
+      </pc:sldChg>
+      <pc:sldChg chg="modSp mod">
+        <pc:chgData name="Justin Hoffman" userId="40d7c2b8f9dba042" providerId="LiveId" clId="{98AE922D-438C-4FBD-AB6F-EAC5EAC34870}" dt="2026-04-25T03:23:10.802" v="184" actId="1035"/>
+        <pc:sldMkLst>
+          <pc:docMk/>
+          <pc:sldMk cId="0" sldId="263"/>
+        </pc:sldMkLst>
+        <pc:spChg chg="mod">
+          <ac:chgData name="Justin Hoffman" userId="40d7c2b8f9dba042" providerId="LiveId" clId="{98AE922D-438C-4FBD-AB6F-EAC5EAC34870}" dt="2026-04-25T03:23:10.802" v="184" actId="1035"/>
+          <ac:spMkLst>
+            <pc:docMk/>
+            <pc:sldMk cId="0" sldId="263"/>
+            <ac:spMk id="8" creationId="{00000000-0000-0000-0000-000000000000}"/>
+          </ac:spMkLst>
+        </pc:spChg>
+        <pc:spChg chg="mod">
+          <ac:chgData name="Justin Hoffman" userId="40d7c2b8f9dba042" providerId="LiveId" clId="{98AE922D-438C-4FBD-AB6F-EAC5EAC34870}" dt="2026-04-25T03:23:10.802" v="184" actId="1035"/>
+          <ac:spMkLst>
+            <pc:docMk/>
+            <pc:sldMk cId="0" sldId="263"/>
+            <ac:spMk id="9" creationId="{00000000-0000-0000-0000-000000000000}"/>
+          </ac:spMkLst>
+        </pc:spChg>
+      </pc:sldChg>
+      <pc:sldChg chg="modSp mod">
+        <pc:chgData name="Justin Hoffman" userId="40d7c2b8f9dba042" providerId="LiveId" clId="{98AE922D-438C-4FBD-AB6F-EAC5EAC34870}" dt="2026-04-25T03:23:52.743" v="194" actId="1036"/>
+        <pc:sldMkLst>
+          <pc:docMk/>
+          <pc:sldMk cId="0" sldId="264"/>
+        </pc:sldMkLst>
+        <pc:spChg chg="mod">
+          <ac:chgData name="Justin Hoffman" userId="40d7c2b8f9dba042" providerId="LiveId" clId="{98AE922D-438C-4FBD-AB6F-EAC5EAC34870}" dt="2026-04-25T03:23:30.697" v="185" actId="255"/>
+          <ac:spMkLst>
+            <pc:docMk/>
+            <pc:sldMk cId="0" sldId="264"/>
+            <ac:spMk id="4" creationId="{00000000-0000-0000-0000-000000000000}"/>
+          </ac:spMkLst>
+        </pc:spChg>
+        <pc:spChg chg="mod">
+          <ac:chgData name="Justin Hoffman" userId="40d7c2b8f9dba042" providerId="LiveId" clId="{98AE922D-438C-4FBD-AB6F-EAC5EAC34870}" dt="2026-04-25T03:23:52.743" v="194" actId="1036"/>
+          <ac:spMkLst>
+            <pc:docMk/>
+            <pc:sldMk cId="0" sldId="264"/>
+            <ac:spMk id="6" creationId="{00000000-0000-0000-0000-000000000000}"/>
+          </ac:spMkLst>
+        </pc:spChg>
+        <pc:spChg chg="mod">
+          <ac:chgData name="Justin Hoffman" userId="40d7c2b8f9dba042" providerId="LiveId" clId="{98AE922D-438C-4FBD-AB6F-EAC5EAC34870}" dt="2026-04-25T03:23:52.743" v="194" actId="1036"/>
+          <ac:spMkLst>
+            <pc:docMk/>
+            <pc:sldMk cId="0" sldId="264"/>
+            <ac:spMk id="8" creationId="{00000000-0000-0000-0000-000000000000}"/>
+          </ac:spMkLst>
+        </pc:spChg>
+        <pc:graphicFrameChg chg="mod">
+          <ac:chgData name="Justin Hoffman" userId="40d7c2b8f9dba042" providerId="LiveId" clId="{98AE922D-438C-4FBD-AB6F-EAC5EAC34870}" dt="2026-04-25T03:23:52.743" v="194" actId="1036"/>
+          <ac:graphicFrameMkLst>
+            <pc:docMk/>
+            <pc:sldMk cId="0" sldId="264"/>
+            <ac:graphicFrameMk id="7" creationId="{00000000-0000-0000-0000-000000000000}"/>
+          </ac:graphicFrameMkLst>
+        </pc:graphicFrameChg>
+        <pc:graphicFrameChg chg="mod">
+          <ac:chgData name="Justin Hoffman" userId="40d7c2b8f9dba042" providerId="LiveId" clId="{98AE922D-438C-4FBD-AB6F-EAC5EAC34870}" dt="2026-04-25T03:23:52.743" v="194" actId="1036"/>
+          <ac:graphicFrameMkLst>
+            <pc:docMk/>
+            <pc:sldMk cId="0" sldId="264"/>
+            <ac:graphicFrameMk id="9" creationId="{00000000-0000-0000-0000-000000000000}"/>
+          </ac:graphicFrameMkLst>
+        </pc:graphicFrameChg>
+      </pc:sldChg>
+      <pc:sldChg chg="addSp delSp modSp mod">
+        <pc:chgData name="Justin Hoffman" userId="40d7c2b8f9dba042" providerId="LiveId" clId="{98AE922D-438C-4FBD-AB6F-EAC5EAC34870}" dt="2026-04-25T15:38:59.052" v="586" actId="20577"/>
+        <pc:sldMkLst>
+          <pc:docMk/>
+          <pc:sldMk cId="0" sldId="265"/>
+        </pc:sldMkLst>
+        <pc:spChg chg="mod">
+          <ac:chgData name="Justin Hoffman" userId="40d7c2b8f9dba042" providerId="LiveId" clId="{98AE922D-438C-4FBD-AB6F-EAC5EAC34870}" dt="2026-04-25T15:38:59.052" v="586" actId="20577"/>
+          <ac:spMkLst>
+            <pc:docMk/>
+            <pc:sldMk cId="0" sldId="265"/>
+            <ac:spMk id="5" creationId="{00000000-0000-0000-0000-000000000000}"/>
+          </ac:spMkLst>
+        </pc:spChg>
+        <pc:picChg chg="add del mod">
+          <ac:chgData name="Justin Hoffman" userId="40d7c2b8f9dba042" providerId="LiveId" clId="{98AE922D-438C-4FBD-AB6F-EAC5EAC34870}" dt="2026-04-25T15:37:45.291" v="565" actId="478"/>
+          <ac:picMkLst>
+            <pc:docMk/>
+            <pc:sldMk cId="0" sldId="265"/>
+            <ac:picMk id="7" creationId="{9A33AA82-E404-BD11-D965-434A29583627}"/>
+          </ac:picMkLst>
+        </pc:picChg>
+        <pc:picChg chg="add mod">
+          <ac:chgData name="Justin Hoffman" userId="40d7c2b8f9dba042" providerId="LiveId" clId="{98AE922D-438C-4FBD-AB6F-EAC5EAC34870}" dt="2026-04-25T15:38:48.811" v="582" actId="1036"/>
+          <ac:picMkLst>
+            <pc:docMk/>
+            <pc:sldMk cId="0" sldId="265"/>
+            <ac:picMk id="8" creationId="{9743B7A9-4CED-8A57-1729-02A735DD604C}"/>
+          </ac:picMkLst>
+        </pc:picChg>
+        <pc:picChg chg="del">
+          <ac:chgData name="Justin Hoffman" userId="40d7c2b8f9dba042" providerId="LiveId" clId="{98AE922D-438C-4FBD-AB6F-EAC5EAC34870}" dt="2026-04-25T05:44:48.433" v="229" actId="478"/>
+          <ac:picMkLst>
+            <pc:docMk/>
+            <pc:sldMk cId="0" sldId="265"/>
+            <ac:picMk id="8" creationId="{C17DBEBD-5221-C0D1-E014-31084F4E31E8}"/>
+          </ac:picMkLst>
+        </pc:picChg>
+      </pc:sldChg>
+      <pc:sldChg chg="addSp delSp modSp mod">
+        <pc:chgData name="Justin Hoffman" userId="40d7c2b8f9dba042" providerId="LiveId" clId="{98AE922D-438C-4FBD-AB6F-EAC5EAC34870}" dt="2026-04-25T03:25:51.287" v="212" actId="1036"/>
+        <pc:sldMkLst>
+          <pc:docMk/>
+          <pc:sldMk cId="0" sldId="267"/>
+        </pc:sldMkLst>
+        <pc:picChg chg="add mod">
+          <ac:chgData name="Justin Hoffman" userId="40d7c2b8f9dba042" providerId="LiveId" clId="{98AE922D-438C-4FBD-AB6F-EAC5EAC34870}" dt="2026-04-25T03:25:51.287" v="212" actId="1036"/>
+          <ac:picMkLst>
+            <pc:docMk/>
+            <pc:sldMk cId="0" sldId="267"/>
+            <ac:picMk id="7" creationId="{724C75C2-3116-4E8F-379A-10ED380FD106}"/>
+          </ac:picMkLst>
+        </pc:picChg>
+        <pc:picChg chg="del">
+          <ac:chgData name="Justin Hoffman" userId="40d7c2b8f9dba042" providerId="LiveId" clId="{98AE922D-438C-4FBD-AB6F-EAC5EAC34870}" dt="2026-04-25T03:24:58.339" v="195" actId="478"/>
+          <ac:picMkLst>
+            <pc:docMk/>
+            <pc:sldMk cId="0" sldId="267"/>
+            <ac:picMk id="8" creationId="{203D6C79-AC04-3E12-630F-105467DA58CE}"/>
+          </ac:picMkLst>
+        </pc:picChg>
+      </pc:sldChg>
+      <pc:sldChg chg="addSp delSp modSp mod">
+        <pc:chgData name="Justin Hoffman" userId="40d7c2b8f9dba042" providerId="LiveId" clId="{98AE922D-438C-4FBD-AB6F-EAC5EAC34870}" dt="2026-04-25T15:40:23.159" v="611" actId="20577"/>
+        <pc:sldMkLst>
+          <pc:docMk/>
+          <pc:sldMk cId="0" sldId="272"/>
+        </pc:sldMkLst>
+        <pc:spChg chg="mod">
+          <ac:chgData name="Justin Hoffman" userId="40d7c2b8f9dba042" providerId="LiveId" clId="{98AE922D-438C-4FBD-AB6F-EAC5EAC34870}" dt="2026-04-25T15:40:23.159" v="611" actId="20577"/>
+          <ac:spMkLst>
+            <pc:docMk/>
+            <pc:sldMk cId="0" sldId="272"/>
+            <ac:spMk id="5" creationId="{00000000-0000-0000-0000-000000000000}"/>
+          </ac:spMkLst>
+        </pc:spChg>
+        <pc:picChg chg="add del mod">
+          <ac:chgData name="Justin Hoffman" userId="40d7c2b8f9dba042" providerId="LiveId" clId="{98AE922D-438C-4FBD-AB6F-EAC5EAC34870}" dt="2026-04-25T15:39:32.142" v="587" actId="478"/>
+          <ac:picMkLst>
+            <pc:docMk/>
+            <pc:sldMk cId="0" sldId="272"/>
+            <ac:picMk id="7" creationId="{083752D7-754F-A049-0247-EBA9365B10BC}"/>
+          </ac:picMkLst>
+        </pc:picChg>
+        <pc:picChg chg="del">
+          <ac:chgData name="Justin Hoffman" userId="40d7c2b8f9dba042" providerId="LiveId" clId="{98AE922D-438C-4FBD-AB6F-EAC5EAC34870}" dt="2026-04-25T05:49:40.020" v="346" actId="478"/>
+          <ac:picMkLst>
+            <pc:docMk/>
+            <pc:sldMk cId="0" sldId="272"/>
+            <ac:picMk id="8" creationId="{99ECF0B6-053B-E4DF-ED2F-D6A5BD36A68F}"/>
+          </ac:picMkLst>
+        </pc:picChg>
+        <pc:picChg chg="add mod">
+          <ac:chgData name="Justin Hoffman" userId="40d7c2b8f9dba042" providerId="LiveId" clId="{98AE922D-438C-4FBD-AB6F-EAC5EAC34870}" dt="2026-04-25T15:40:03.356" v="603" actId="1036"/>
+          <ac:picMkLst>
+            <pc:docMk/>
+            <pc:sldMk cId="0" sldId="272"/>
+            <ac:picMk id="8" creationId="{DE644991-4434-58E9-21C4-A6CB90D28B55}"/>
+          </ac:picMkLst>
+        </pc:picChg>
+      </pc:sldChg>
+      <pc:sldChg chg="addSp delSp modSp mod">
+        <pc:chgData name="Justin Hoffman" userId="40d7c2b8f9dba042" providerId="LiveId" clId="{98AE922D-438C-4FBD-AB6F-EAC5EAC34870}" dt="2026-04-25T15:41:48.700" v="637" actId="20577"/>
+        <pc:sldMkLst>
+          <pc:docMk/>
+          <pc:sldMk cId="0" sldId="273"/>
+        </pc:sldMkLst>
+        <pc:spChg chg="mod">
+          <ac:chgData name="Justin Hoffman" userId="40d7c2b8f9dba042" providerId="LiveId" clId="{98AE922D-438C-4FBD-AB6F-EAC5EAC34870}" dt="2026-04-25T15:41:48.700" v="637" actId="20577"/>
+          <ac:spMkLst>
+            <pc:docMk/>
+            <pc:sldMk cId="0" sldId="273"/>
+            <ac:spMk id="5" creationId="{00000000-0000-0000-0000-000000000000}"/>
+          </ac:spMkLst>
+        </pc:spChg>
+        <pc:picChg chg="add del mod">
+          <ac:chgData name="Justin Hoffman" userId="40d7c2b8f9dba042" providerId="LiveId" clId="{98AE922D-438C-4FBD-AB6F-EAC5EAC34870}" dt="2026-04-25T15:40:28.825" v="612" actId="478"/>
+          <ac:picMkLst>
+            <pc:docMk/>
+            <pc:sldMk cId="0" sldId="273"/>
+            <ac:picMk id="7" creationId="{65775446-E8F4-0502-500D-C4A798DC643A}"/>
+          </ac:picMkLst>
+        </pc:picChg>
+        <pc:picChg chg="add mod">
+          <ac:chgData name="Justin Hoffman" userId="40d7c2b8f9dba042" providerId="LiveId" clId="{98AE922D-438C-4FBD-AB6F-EAC5EAC34870}" dt="2026-04-25T15:41:07.119" v="627" actId="1036"/>
+          <ac:picMkLst>
+            <pc:docMk/>
+            <pc:sldMk cId="0" sldId="273"/>
+            <ac:picMk id="8" creationId="{3CF88791-8208-521D-4CB7-33B57ECE7FC1}"/>
+          </ac:picMkLst>
+        </pc:picChg>
+        <pc:picChg chg="del">
+          <ac:chgData name="Justin Hoffman" userId="40d7c2b8f9dba042" providerId="LiveId" clId="{98AE922D-438C-4FBD-AB6F-EAC5EAC34870}" dt="2026-04-25T05:50:35.808" v="369" actId="478"/>
+          <ac:picMkLst>
+            <pc:docMk/>
+            <pc:sldMk cId="0" sldId="273"/>
+            <ac:picMk id="8" creationId="{7FBC32C6-F401-1DDE-997E-2D9C2EEB874D}"/>
+          </ac:picMkLst>
+        </pc:picChg>
+      </pc:sldChg>
+      <pc:sldChg chg="addSp delSp modSp mod">
+        <pc:chgData name="Justin Hoffman" userId="40d7c2b8f9dba042" providerId="LiveId" clId="{98AE922D-438C-4FBD-AB6F-EAC5EAC34870}" dt="2026-04-25T15:42:34.483" v="654" actId="1036"/>
+        <pc:sldMkLst>
+          <pc:docMk/>
+          <pc:sldMk cId="0" sldId="274"/>
+        </pc:sldMkLst>
+        <pc:spChg chg="mod">
+          <ac:chgData name="Justin Hoffman" userId="40d7c2b8f9dba042" providerId="LiveId" clId="{98AE922D-438C-4FBD-AB6F-EAC5EAC34870}" dt="2026-04-25T05:53:46.844" v="406" actId="20577"/>
+          <ac:spMkLst>
+            <pc:docMk/>
+            <pc:sldMk cId="0" sldId="274"/>
+            <ac:spMk id="5" creationId="{00000000-0000-0000-0000-000000000000}"/>
+          </ac:spMkLst>
+        </pc:spChg>
+        <pc:picChg chg="add del mod">
+          <ac:chgData name="Justin Hoffman" userId="40d7c2b8f9dba042" providerId="LiveId" clId="{98AE922D-438C-4FBD-AB6F-EAC5EAC34870}" dt="2026-04-25T15:42:06.196" v="638" actId="478"/>
+          <ac:picMkLst>
+            <pc:docMk/>
+            <pc:sldMk cId="0" sldId="274"/>
+            <ac:picMk id="7" creationId="{E069DFBF-5372-9C63-1447-698621E56998}"/>
+          </ac:picMkLst>
+        </pc:picChg>
+        <pc:picChg chg="del">
+          <ac:chgData name="Justin Hoffman" userId="40d7c2b8f9dba042" providerId="LiveId" clId="{98AE922D-438C-4FBD-AB6F-EAC5EAC34870}" dt="2026-04-25T05:53:49.332" v="407" actId="478"/>
+          <ac:picMkLst>
+            <pc:docMk/>
+            <pc:sldMk cId="0" sldId="274"/>
+            <ac:picMk id="8" creationId="{26A6BC54-E04E-FD32-3BEC-14DADFF9E005}"/>
+          </ac:picMkLst>
+        </pc:picChg>
+        <pc:picChg chg="add mod">
+          <ac:chgData name="Justin Hoffman" userId="40d7c2b8f9dba042" providerId="LiveId" clId="{98AE922D-438C-4FBD-AB6F-EAC5EAC34870}" dt="2026-04-25T15:42:34.483" v="654" actId="1036"/>
+          <ac:picMkLst>
+            <pc:docMk/>
+            <pc:sldMk cId="0" sldId="274"/>
+            <ac:picMk id="8" creationId="{29564311-76F5-EB79-1A98-6F93BE84AD6E}"/>
+          </ac:picMkLst>
+        </pc:picChg>
+      </pc:sldChg>
+      <pc:sldChg chg="addSp delSp modSp mod">
+        <pc:chgData name="Justin Hoffman" userId="40d7c2b8f9dba042" providerId="LiveId" clId="{98AE922D-438C-4FBD-AB6F-EAC5EAC34870}" dt="2026-04-25T15:46:06.824" v="855" actId="20577"/>
+        <pc:sldMkLst>
+          <pc:docMk/>
+          <pc:sldMk cId="0" sldId="275"/>
+        </pc:sldMkLst>
+        <pc:spChg chg="mod">
+          <ac:chgData name="Justin Hoffman" userId="40d7c2b8f9dba042" providerId="LiveId" clId="{98AE922D-438C-4FBD-AB6F-EAC5EAC34870}" dt="2026-04-25T15:46:06.824" v="855" actId="20577"/>
+          <ac:spMkLst>
+            <pc:docMk/>
+            <pc:sldMk cId="0" sldId="275"/>
+            <ac:spMk id="5" creationId="{00000000-0000-0000-0000-000000000000}"/>
+          </ac:spMkLst>
+        </pc:spChg>
+        <pc:picChg chg="add del mod">
+          <ac:chgData name="Justin Hoffman" userId="40d7c2b8f9dba042" providerId="LiveId" clId="{98AE922D-438C-4FBD-AB6F-EAC5EAC34870}" dt="2026-04-25T15:42:55.257" v="655" actId="478"/>
+          <ac:picMkLst>
+            <pc:docMk/>
+            <pc:sldMk cId="0" sldId="275"/>
+            <ac:picMk id="7" creationId="{F9B89590-A228-D295-EB5D-16DAA53BCE49}"/>
+          </ac:picMkLst>
+        </pc:picChg>
+        <pc:picChg chg="add mod">
+          <ac:chgData name="Justin Hoffman" userId="40d7c2b8f9dba042" providerId="LiveId" clId="{98AE922D-438C-4FBD-AB6F-EAC5EAC34870}" dt="2026-04-25T15:43:27.612" v="679" actId="1036"/>
+          <ac:picMkLst>
+            <pc:docMk/>
+            <pc:sldMk cId="0" sldId="275"/>
+            <ac:picMk id="8" creationId="{88C5AA48-6CB4-FC70-7292-9F25A73D566F}"/>
+          </ac:picMkLst>
+        </pc:picChg>
+        <pc:picChg chg="del">
+          <ac:chgData name="Justin Hoffman" userId="40d7c2b8f9dba042" providerId="LiveId" clId="{98AE922D-438C-4FBD-AB6F-EAC5EAC34870}" dt="2026-04-25T05:54:33.842" v="426" actId="478"/>
+          <ac:picMkLst>
+            <pc:docMk/>
+            <pc:sldMk cId="0" sldId="275"/>
+            <ac:picMk id="8" creationId="{C2417921-B87D-1463-BEA4-B2F6BE87ED1C}"/>
+          </ac:picMkLst>
+        </pc:picChg>
+      </pc:sldChg>
+      <pc:sldChg chg="addSp delSp modSp mod">
+        <pc:chgData name="Justin Hoffman" userId="40d7c2b8f9dba042" providerId="LiveId" clId="{98AE922D-438C-4FBD-AB6F-EAC5EAC34870}" dt="2026-04-25T15:48:54.947" v="916" actId="20577"/>
+        <pc:sldMkLst>
+          <pc:docMk/>
+          <pc:sldMk cId="0" sldId="276"/>
+        </pc:sldMkLst>
+        <pc:spChg chg="mod">
+          <ac:chgData name="Justin Hoffman" userId="40d7c2b8f9dba042" providerId="LiveId" clId="{98AE922D-438C-4FBD-AB6F-EAC5EAC34870}" dt="2026-04-25T15:48:54.947" v="916" actId="20577"/>
+          <ac:spMkLst>
+            <pc:docMk/>
+            <pc:sldMk cId="0" sldId="276"/>
+            <ac:spMk id="5" creationId="{00000000-0000-0000-0000-000000000000}"/>
+          </ac:spMkLst>
+        </pc:spChg>
+        <pc:picChg chg="add del mod">
+          <ac:chgData name="Justin Hoffman" userId="40d7c2b8f9dba042" providerId="LiveId" clId="{98AE922D-438C-4FBD-AB6F-EAC5EAC34870}" dt="2026-04-25T15:46:12.037" v="856" actId="478"/>
+          <ac:picMkLst>
+            <pc:docMk/>
+            <pc:sldMk cId="0" sldId="276"/>
+            <ac:picMk id="7" creationId="{93FC38FF-76EF-28DD-4412-45A940D6F962}"/>
+          </ac:picMkLst>
+        </pc:picChg>
+        <pc:picChg chg="add del mod">
+          <ac:chgData name="Justin Hoffman" userId="40d7c2b8f9dba042" providerId="LiveId" clId="{98AE922D-438C-4FBD-AB6F-EAC5EAC34870}" dt="2026-04-25T15:47:22.203" v="874" actId="478"/>
+          <ac:picMkLst>
+            <pc:docMk/>
+            <pc:sldMk cId="0" sldId="276"/>
+            <ac:picMk id="8" creationId="{435E1758-73DB-E68E-6017-FA00C9AE262B}"/>
+          </ac:picMkLst>
+        </pc:picChg>
+        <pc:picChg chg="del">
+          <ac:chgData name="Justin Hoffman" userId="40d7c2b8f9dba042" providerId="LiveId" clId="{98AE922D-438C-4FBD-AB6F-EAC5EAC34870}" dt="2026-04-25T05:57:09.814" v="464" actId="478"/>
+          <ac:picMkLst>
+            <pc:docMk/>
+            <pc:sldMk cId="0" sldId="276"/>
+            <ac:picMk id="8" creationId="{591D2A93-C132-774C-24E3-8E4C73C2DC2C}"/>
+          </ac:picMkLst>
+        </pc:picChg>
+        <pc:picChg chg="add mod">
+          <ac:chgData name="Justin Hoffman" userId="40d7c2b8f9dba042" providerId="LiveId" clId="{98AE922D-438C-4FBD-AB6F-EAC5EAC34870}" dt="2026-04-25T15:48:01.419" v="890" actId="1036"/>
+          <ac:picMkLst>
+            <pc:docMk/>
+            <pc:sldMk cId="0" sldId="276"/>
+            <ac:picMk id="10" creationId="{8978B677-D81D-C778-2E62-0DAE6A7DFC1F}"/>
+          </ac:picMkLst>
+        </pc:picChg>
+      </pc:sldChg>
+      <pc:sldChg chg="addSp modSp mod">
+        <pc:chgData name="Justin Hoffman" userId="40d7c2b8f9dba042" providerId="LiveId" clId="{98AE922D-438C-4FBD-AB6F-EAC5EAC34870}" dt="2026-04-25T16:13:00.018" v="1132" actId="20577"/>
+        <pc:sldMkLst>
+          <pc:docMk/>
+          <pc:sldMk cId="0" sldId="277"/>
+        </pc:sldMkLst>
+        <pc:spChg chg="mod">
+          <ac:chgData name="Justin Hoffman" userId="40d7c2b8f9dba042" providerId="LiveId" clId="{98AE922D-438C-4FBD-AB6F-EAC5EAC34870}" dt="2026-04-25T15:49:26.784" v="924" actId="20577"/>
+          <ac:spMkLst>
+            <pc:docMk/>
+            <pc:sldMk cId="0" sldId="277"/>
+            <ac:spMk id="9" creationId="{00000000-0000-0000-0000-000000000000}"/>
+          </ac:spMkLst>
+        </pc:spChg>
+        <pc:spChg chg="mod">
+          <ac:chgData name="Justin Hoffman" userId="40d7c2b8f9dba042" providerId="LiveId" clId="{98AE922D-438C-4FBD-AB6F-EAC5EAC34870}" dt="2026-04-25T16:04:57.589" v="1048"/>
+          <ac:spMkLst>
+            <pc:docMk/>
+            <pc:sldMk cId="0" sldId="277"/>
+            <ac:spMk id="10" creationId="{00000000-0000-0000-0000-000000000000}"/>
+          </ac:spMkLst>
+        </pc:spChg>
+        <pc:spChg chg="mod">
+          <ac:chgData name="Justin Hoffman" userId="40d7c2b8f9dba042" providerId="LiveId" clId="{98AE922D-438C-4FBD-AB6F-EAC5EAC34870}" dt="2026-04-25T16:09:52.741" v="1114" actId="20577"/>
+          <ac:spMkLst>
+            <pc:docMk/>
+            <pc:sldMk cId="0" sldId="277"/>
+            <ac:spMk id="12" creationId="{00000000-0000-0000-0000-000000000000}"/>
+          </ac:spMkLst>
+        </pc:spChg>
+        <pc:spChg chg="mod">
+          <ac:chgData name="Justin Hoffman" userId="40d7c2b8f9dba042" providerId="LiveId" clId="{98AE922D-438C-4FBD-AB6F-EAC5EAC34870}" dt="2026-04-25T16:13:00.018" v="1132" actId="20577"/>
+          <ac:spMkLst>
+            <pc:docMk/>
+            <pc:sldMk cId="0" sldId="277"/>
+            <ac:spMk id="15" creationId="{00000000-0000-0000-0000-000000000000}"/>
+          </ac:spMkLst>
+        </pc:spChg>
+        <pc:spChg chg="add">
+          <ac:chgData name="Justin Hoffman" userId="40d7c2b8f9dba042" providerId="LiveId" clId="{98AE922D-438C-4FBD-AB6F-EAC5EAC34870}" dt="2026-04-25T16:03:35.541" v="1033"/>
+          <ac:spMkLst>
+            <pc:docMk/>
+            <pc:sldMk cId="0" sldId="277"/>
+            <ac:spMk id="16" creationId="{37F4185E-2CE2-A867-5B5D-8DE793910520}"/>
+          </ac:spMkLst>
+        </pc:spChg>
+        <pc:spChg chg="add">
+          <ac:chgData name="Justin Hoffman" userId="40d7c2b8f9dba042" providerId="LiveId" clId="{98AE922D-438C-4FBD-AB6F-EAC5EAC34870}" dt="2026-04-25T16:10:19.957" v="1115"/>
+          <ac:spMkLst>
+            <pc:docMk/>
+            <pc:sldMk cId="0" sldId="277"/>
+            <ac:spMk id="17" creationId="{13A048EB-EEB4-4AAC-F0EC-0A57623D43CC}"/>
+          </ac:spMkLst>
+        </pc:spChg>
+      </pc:sldChg>
+    </pc:docChg>
+  </pc:docChgLst>
+</pc:chgInfo>
 </file>
 
 <file path=ppt/notesMasters/notesMaster1.xml><?xml version="1.0" encoding="utf-8"?>
@@ -778,7 +1354,7 @@
               <a:buNone/>
             </a:pPr>
             <a:r>
-              <a:rPr lang="en-US" sz="1300" dirty="0">
+              <a:rPr lang="en-US" sz="1600" dirty="0">
                 <a:solidFill>
                   <a:srgbClr val="A8C4E0"/>
                 </a:solidFill>
@@ -788,14 +1364,14 @@
               </a:rPr>
               <a:t>Peak</a:t>
             </a:r>
-            <a:endParaRPr lang="en-US" sz="1300" dirty="0"/>
+            <a:endParaRPr lang="en-US" sz="1600" dirty="0"/>
           </a:p>
           <a:p>
             <a:pPr marL="0" indent="0" algn="ctr">
               <a:buNone/>
             </a:pPr>
             <a:r>
-              <a:rPr lang="en-US" sz="1300" dirty="0">
+              <a:rPr lang="en-US" sz="1600" dirty="0">
                 <a:solidFill>
                   <a:srgbClr val="A8C4E0"/>
                 </a:solidFill>
@@ -805,7 +1381,7 @@
               </a:rPr>
               <a:t>Speedup</a:t>
             </a:r>
-            <a:endParaRPr lang="en-US" sz="1300" dirty="0"/>
+            <a:endParaRPr lang="en-US" sz="1600" dirty="0"/>
           </a:p>
         </p:txBody>
       </p:sp>
@@ -907,7 +1483,7 @@
               <a:buNone/>
             </a:pPr>
             <a:r>
-              <a:rPr lang="en-US" sz="1300" dirty="0">
+              <a:rPr lang="en-US" sz="1600" dirty="0">
                 <a:solidFill>
                   <a:srgbClr val="A8C4E0"/>
                 </a:solidFill>
@@ -917,14 +1493,14 @@
               </a:rPr>
               <a:t>Records</a:t>
             </a:r>
-            <a:endParaRPr lang="en-US" sz="1300" dirty="0"/>
+            <a:endParaRPr lang="en-US" sz="1600" dirty="0"/>
           </a:p>
           <a:p>
             <a:pPr marL="0" indent="0" algn="ctr">
               <a:buNone/>
             </a:pPr>
             <a:r>
-              <a:rPr lang="en-US" sz="1300" dirty="0">
+              <a:rPr lang="en-US" sz="1600" dirty="0">
                 <a:solidFill>
                   <a:srgbClr val="A8C4E0"/>
                 </a:solidFill>
@@ -934,7 +1510,7 @@
               </a:rPr>
               <a:t>Tested</a:t>
             </a:r>
-            <a:endParaRPr lang="en-US" sz="1300" dirty="0"/>
+            <a:endParaRPr lang="en-US" sz="1600" dirty="0"/>
           </a:p>
         </p:txBody>
       </p:sp>
@@ -1036,7 +1612,7 @@
               <a:buNone/>
             </a:pPr>
             <a:r>
-              <a:rPr lang="en-US" sz="1300" dirty="0">
+              <a:rPr lang="en-US" sz="1600" dirty="0">
                 <a:solidFill>
                   <a:srgbClr val="A8C4E0"/>
                 </a:solidFill>
@@ -1046,7 +1622,7 @@
               </a:rPr>
               <a:t>Implementations</a:t>
             </a:r>
-            <a:endParaRPr lang="en-US" sz="1300" dirty="0"/>
+            <a:endParaRPr lang="en-US" sz="1600" dirty="0"/>
           </a:p>
         </p:txBody>
       </p:sp>
@@ -1148,7 +1724,7 @@
               <a:buNone/>
             </a:pPr>
             <a:r>
-              <a:rPr lang="en-US" sz="1300" dirty="0">
+              <a:rPr lang="en-US" sz="1600" dirty="0">
                 <a:solidFill>
                   <a:srgbClr val="A8C4E0"/>
                 </a:solidFill>
@@ -1158,7 +1734,7 @@
               </a:rPr>
               <a:t>Environments</a:t>
             </a:r>
-            <a:endParaRPr lang="en-US" sz="1300" dirty="0"/>
+            <a:endParaRPr lang="en-US" sz="1600" dirty="0"/>
           </a:p>
         </p:txBody>
       </p:sp>
@@ -1462,9 +2038,6 @@
           <a:bodyPr wrap="square" rtlCol="0" anchor="ctr"/>
           <a:lstStyle/>
           <a:p>
-            <a:pPr marL="0" indent="0">
-              <a:buNone/>
-            </a:pPr>
             <a:r>
               <a:rPr lang="en-US" sz="1600" b="1" dirty="0">
                 <a:solidFill>
@@ -1481,11 +2054,19 @@
                 <a:solidFill>
                   <a:srgbClr val="444444"/>
                 </a:solidFill>
-                <a:latin typeface="Calibri" pitchFamily="34" charset="0"/>
-                <a:ea typeface="Calibri" pitchFamily="34" charset="-122"/>
-                <a:cs typeface="Calibri" pitchFamily="34" charset="-120"/>
-              </a:rPr>
-              <a:t>Scales to 9.11x at 16 threads. Efficiency stays above 0.8 through 8 threads.
+              </a:rPr>
+              <a:t>Scales to 8.41x at 16 threads. Efficiency stays above 0.8 through 4 threads.</a:t>
+            </a:r>
+            <a:r>
+              <a:rPr lang="en-US" sz="1600" dirty="0">
+                <a:solidFill>
+                  <a:srgbClr val="444444"/>
+                </a:solidFill>
+                <a:latin typeface="Calibri" pitchFamily="34" charset="0"/>
+                <a:ea typeface="Calibri" pitchFamily="34" charset="-122"/>
+                <a:cs typeface="Calibri" pitchFamily="34" charset="-120"/>
+              </a:rPr>
+              <a:t>
 </a:t>
             </a:r>
             <a:r>
@@ -1504,13 +2085,9 @@
                 <a:solidFill>
                   <a:srgbClr val="444444"/>
                 </a:solidFill>
-                <a:latin typeface="Calibri" pitchFamily="34" charset="0"/>
-                <a:ea typeface="Calibri" pitchFamily="34" charset="-122"/>
-                <a:cs typeface="Calibri" pitchFamily="34" charset="-120"/>
               </a:rPr>
               <a:t>Tops out at 3.62x at 8 threads due to fewer cores and higher thread overhead.</a:t>
             </a:r>
-            <a:endParaRPr lang="en-US" sz="1600" dirty="0"/>
           </a:p>
         </p:txBody>
       </p:sp>
@@ -1519,7 +2096,7 @@
           <p:cNvPr id="8" name="Picture 7">
             <a:extLst>
               <a:ext uri="{FF2B5EF4-FFF2-40B4-BE49-F238E27FC236}">
-                <a16:creationId xmlns:a16="http://schemas.microsoft.com/office/drawing/2014/main" id="{C17DBEBD-5221-C0D1-E014-31084F4E31E8}"/>
+                <a16:creationId xmlns:a16="http://schemas.microsoft.com/office/drawing/2014/main" id="{9743B7A9-4CED-8A57-1729-02A735DD604C}"/>
               </a:ext>
             </a:extLst>
           </p:cNvPr>
@@ -1536,8 +2113,8 @@
         </p:blipFill>
         <p:spPr>
           <a:xfrm>
-            <a:off x="1083852" y="2098590"/>
-            <a:ext cx="6976295" cy="2939858"/>
+            <a:off x="1100200" y="2100432"/>
+            <a:ext cx="6943600" cy="2926080"/>
           </a:xfrm>
           <a:prstGeom prst="rect">
             <a:avLst/>
@@ -1982,10 +2559,10 @@
       </p:sp>
       <p:pic>
         <p:nvPicPr>
-          <p:cNvPr id="8" name="Picture 7">
+          <p:cNvPr id="7" name="Picture 6">
             <a:extLst>
               <a:ext uri="{FF2B5EF4-FFF2-40B4-BE49-F238E27FC236}">
-                <a16:creationId xmlns:a16="http://schemas.microsoft.com/office/drawing/2014/main" id="{203D6C79-AC04-3E12-630F-105467DA58CE}"/>
+                <a16:creationId xmlns:a16="http://schemas.microsoft.com/office/drawing/2014/main" id="{724C75C2-3116-4E8F-379A-10ED380FD106}"/>
               </a:ext>
             </a:extLst>
           </p:cNvPr>
@@ -2002,8 +2579,8 @@
         </p:blipFill>
         <p:spPr>
           <a:xfrm>
-            <a:off x="938985" y="2098590"/>
-            <a:ext cx="7266029" cy="3017520"/>
+            <a:off x="938986" y="2100942"/>
+            <a:ext cx="7266027" cy="3017520"/>
           </a:xfrm>
           <a:prstGeom prst="rect">
             <a:avLst/>
@@ -4222,7 +4799,7 @@
                 <a:ea typeface="Calibri" pitchFamily="34" charset="-122"/>
                 <a:cs typeface="Calibri" pitchFamily="34" charset="-120"/>
               </a:rPr>
-              <a:t>Scales cleanly to 6.30x at 16 procs. Up from 1.88x in v1.
+              <a:t>Scales cleanly to 6.55x at 16 procs. Up from 1.88x in v1.
 </a:t>
             </a:r>
             <a:r>
@@ -4245,7 +4822,7 @@
                 <a:ea typeface="Calibri" pitchFamily="34" charset="-122"/>
                 <a:cs typeface="Calibri" pitchFamily="34" charset="-120"/>
               </a:rPr>
-              <a:t>Reaches 2.98x at 8 procs. Up from 1.28x in v1.</a:t>
+              <a:t>Reaches 2.67x at 8 procs. Up from 1.28x in v1.</a:t>
             </a:r>
             <a:endParaRPr lang="en-US" sz="1600" dirty="0"/>
           </a:p>
@@ -4256,7 +4833,7 @@
           <p:cNvPr id="8" name="Picture 7">
             <a:extLst>
               <a:ext uri="{FF2B5EF4-FFF2-40B4-BE49-F238E27FC236}">
-                <a16:creationId xmlns:a16="http://schemas.microsoft.com/office/drawing/2014/main" id="{99ECF0B6-053B-E4DF-ED2F-D6A5BD36A68F}"/>
+                <a16:creationId xmlns:a16="http://schemas.microsoft.com/office/drawing/2014/main" id="{DE644991-4434-58E9-21C4-A6CB90D28B55}"/>
               </a:ext>
             </a:extLst>
           </p:cNvPr>
@@ -4273,8 +4850,8 @@
         </p:blipFill>
         <p:spPr>
           <a:xfrm>
-            <a:off x="1083852" y="2098590"/>
-            <a:ext cx="6976295" cy="2939858"/>
+            <a:off x="991706" y="2100432"/>
+            <a:ext cx="7160588" cy="3017520"/>
           </a:xfrm>
           <a:prstGeom prst="rect">
             <a:avLst/>
@@ -4455,7 +5032,7 @@
                 <a:ea typeface="Calibri" pitchFamily="34" charset="-122"/>
                 <a:cs typeface="Calibri" pitchFamily="34" charset="-120"/>
               </a:rPr>
-              <a:t>Peak jumps to 8.06x at 8p x 16t. Up from 6.18x in v1. Heatmap is now much darker.
+              <a:t>Peak jumps to 8.06x at 4p x 16t. Up from 6.18x in v1. Heatmap is now much darker.
 </a:t>
             </a:r>
             <a:r>
@@ -4478,7 +5055,7 @@
                 <a:ea typeface="Calibri" pitchFamily="34" charset="-122"/>
                 <a:cs typeface="Calibri" pitchFamily="34" charset="-120"/>
               </a:rPr>
-              <a:t>Best config hits 3.48x at 2p x 8t. Up from 2.90x in v1.</a:t>
+              <a:t>Best config hits 3.13x at 2p x 8t. Up from 2.90x in v1.</a:t>
             </a:r>
             <a:endParaRPr lang="en-US" sz="1600" dirty="0"/>
           </a:p>
@@ -4489,7 +5066,7 @@
           <p:cNvPr id="8" name="Picture 7">
             <a:extLst>
               <a:ext uri="{FF2B5EF4-FFF2-40B4-BE49-F238E27FC236}">
-                <a16:creationId xmlns:a16="http://schemas.microsoft.com/office/drawing/2014/main" id="{7FBC32C6-F401-1DDE-997E-2D9C2EEB874D}"/>
+                <a16:creationId xmlns:a16="http://schemas.microsoft.com/office/drawing/2014/main" id="{3CF88791-8208-521D-4CB7-33B57ECE7FC1}"/>
               </a:ext>
             </a:extLst>
           </p:cNvPr>
@@ -4506,7 +5083,7 @@
         </p:blipFill>
         <p:spPr>
           <a:xfrm>
-            <a:off x="938986" y="2098590"/>
+            <a:off x="938986" y="2104464"/>
             <a:ext cx="7266027" cy="3017520"/>
           </a:xfrm>
           <a:prstGeom prst="rect">
@@ -4688,7 +5265,7 @@
                 <a:ea typeface="Calibri" pitchFamily="34" charset="-122"/>
                 <a:cs typeface="Calibri" pitchFamily="34" charset="-120"/>
               </a:rPr>
-              <a:t>Efficiency stays above 0.8 through 8 threads on Expanse. Drops at 16.
+              <a:t>Efficiency stays above 0.8 through 4 threads on Expanse. Drops at 16.
 </a:t>
             </a:r>
             <a:r>
@@ -4722,7 +5299,7 @@
           <p:cNvPr id="8" name="Picture 7">
             <a:extLst>
               <a:ext uri="{FF2B5EF4-FFF2-40B4-BE49-F238E27FC236}">
-                <a16:creationId xmlns:a16="http://schemas.microsoft.com/office/drawing/2014/main" id="{26A6BC54-E04E-FD32-3BEC-14DADFF9E005}"/>
+                <a16:creationId xmlns:a16="http://schemas.microsoft.com/office/drawing/2014/main" id="{29564311-76F5-EB79-1A98-6F93BE84AD6E}"/>
               </a:ext>
             </a:extLst>
           </p:cNvPr>
@@ -4739,7 +5316,7 @@
         </p:blipFill>
         <p:spPr>
           <a:xfrm>
-            <a:off x="991706" y="2098590"/>
+            <a:off x="634703" y="2100432"/>
             <a:ext cx="7160588" cy="3017520"/>
           </a:xfrm>
           <a:prstGeom prst="rect">
@@ -4872,7 +5449,7 @@
               <a:buChar char="•"/>
             </a:pPr>
             <a:r>
-              <a:rPr lang="en-US" sz="1600" dirty="0">
+              <a:rPr lang="en-US" dirty="0">
                 <a:solidFill>
                   <a:srgbClr val="1A1A1A"/>
                 </a:solidFill>
@@ -4882,7 +5459,7 @@
               </a:rPr>
               <a:t>All features are integer-coded categories</a:t>
             </a:r>
-            <a:endParaRPr lang="en-US" sz="1600" dirty="0"/>
+            <a:endParaRPr lang="en-US" dirty="0"/>
           </a:p>
           <a:p>
             <a:pPr marL="342900" indent="-342900">
@@ -4893,7 +5470,7 @@
               <a:buChar char="•"/>
             </a:pPr>
             <a:r>
-              <a:rPr lang="en-US" sz="1600" dirty="0">
+              <a:rPr lang="en-US" dirty="0">
                 <a:solidFill>
                   <a:srgbClr val="1A1A1A"/>
                 </a:solidFill>
@@ -4901,9 +5478,9 @@
                 <a:ea typeface="Calibri" pitchFamily="34" charset="-122"/>
                 <a:cs typeface="Calibri" pitchFamily="34" charset="-120"/>
               </a:rPr>
-              <a:t>Training and classification processed row by row: no dependencies between rows, embarrassingly parallel</a:t>
-            </a:r>
-            <a:endParaRPr lang="en-US" sz="1600" dirty="0"/>
+              <a:t>Training and classification processed row by row: no dependencies between rows</a:t>
+            </a:r>
+            <a:endParaRPr lang="en-US" dirty="0"/>
           </a:p>
           <a:p>
             <a:pPr marL="342900" indent="-342900">
@@ -4914,7 +5491,7 @@
               <a:buChar char="•"/>
             </a:pPr>
             <a:r>
-              <a:rPr lang="en-US" sz="1600" dirty="0">
+              <a:rPr lang="en-US" dirty="0">
                 <a:solidFill>
                   <a:srgbClr val="1A1A1A"/>
                 </a:solidFill>
@@ -4924,7 +5501,7 @@
               </a:rPr>
               <a:t>5-fold cross-validation: split data into 5 parts, train on 4, test on 1, rotate and repeat</a:t>
             </a:r>
-            <a:endParaRPr lang="en-US" sz="1600" dirty="0"/>
+            <a:endParaRPr lang="en-US" dirty="0"/>
           </a:p>
           <a:p>
             <a:pPr marL="342900" indent="-342900">
@@ -4935,7 +5512,7 @@
               <a:buChar char="•"/>
             </a:pPr>
             <a:r>
-              <a:rPr lang="en-US" sz="1600" dirty="0">
+              <a:rPr lang="en-US" dirty="0">
                 <a:solidFill>
                   <a:srgbClr val="1A1A1A"/>
                 </a:solidFill>
@@ -4945,7 +5522,7 @@
               </a:rPr>
               <a:t>ML metrics reported: accuracy and confusion matrix per fold</a:t>
             </a:r>
-            <a:endParaRPr lang="en-US" sz="1600" dirty="0"/>
+            <a:endParaRPr lang="en-US" dirty="0"/>
           </a:p>
           <a:p>
             <a:pPr marL="342900" indent="-342900">
@@ -4953,7 +5530,7 @@
               <a:buChar char="•"/>
             </a:pPr>
             <a:r>
-              <a:rPr lang="en-US" sz="1600" dirty="0">
+              <a:rPr lang="en-US" dirty="0">
                 <a:solidFill>
                   <a:srgbClr val="1A1A1A"/>
                 </a:solidFill>
@@ -4963,7 +5540,7 @@
               </a:rPr>
               <a:t>Log probabilities for numerical stability; Laplace smoothing (alpha=1.0) for unseen values</a:t>
             </a:r>
-            <a:endParaRPr lang="en-US" sz="1600" dirty="0"/>
+            <a:endParaRPr lang="en-US" dirty="0"/>
           </a:p>
         </p:txBody>
       </p:sp>
@@ -5112,10 +5689,13 @@
           <a:lstStyle/>
           <a:p>
             <a:pPr marL="0" indent="0">
+              <a:lnSpc>
+                <a:spcPct val="150000"/>
+              </a:lnSpc>
               <a:buNone/>
             </a:pPr>
             <a:r>
-              <a:rPr lang="en-US" sz="1400" b="1" dirty="0">
+              <a:rPr lang="en-US" sz="1600" b="1" dirty="0">
                 <a:solidFill>
                   <a:srgbClr val="0D3B6E"/>
                 </a:solidFill>
@@ -5126,7 +5706,7 @@
               <a:t>P(y)</a:t>
             </a:r>
             <a:r>
-              <a:rPr lang="en-US" sz="1400" dirty="0">
+              <a:rPr lang="en-US" sz="1600" dirty="0">
                 <a:solidFill>
                   <a:srgbClr val="444444"/>
                 </a:solidFill>
@@ -5138,7 +5718,7 @@
 </a:t>
             </a:r>
             <a:r>
-              <a:rPr lang="en-US" sz="1400" b="1" dirty="0">
+              <a:rPr lang="en-US" sz="1600" b="1" dirty="0">
                 <a:solidFill>
                   <a:srgbClr val="0D3B6E"/>
                 </a:solidFill>
@@ -5149,7 +5729,7 @@
               <a:t>P(xᵢ | y)</a:t>
             </a:r>
             <a:r>
-              <a:rPr lang="en-US" sz="1400" dirty="0">
+              <a:rPr lang="en-US" sz="1600" dirty="0">
                 <a:solidFill>
                   <a:srgbClr val="444444"/>
                 </a:solidFill>
@@ -5161,7 +5741,7 @@
 </a:t>
             </a:r>
             <a:r>
-              <a:rPr lang="en-US" sz="1400" b="1" dirty="0">
+              <a:rPr lang="en-US" sz="1600" b="1" dirty="0">
                 <a:solidFill>
                   <a:srgbClr val="0D3B6E"/>
                 </a:solidFill>
@@ -5172,7 +5752,7 @@
               <a:t>Predict</a:t>
             </a:r>
             <a:r>
-              <a:rPr lang="en-US" sz="1400" dirty="0">
+              <a:rPr lang="en-US" sz="1600" dirty="0">
                 <a:solidFill>
                   <a:srgbClr val="444444"/>
                 </a:solidFill>
@@ -5182,7 +5762,7 @@
               </a:rPr>
               <a:t> = argmax [ log P(y) + Σ log P(xᵢ|y) ]</a:t>
             </a:r>
-            <a:endParaRPr lang="en-US" sz="1400" dirty="0"/>
+            <a:endParaRPr lang="en-US" sz="1600" dirty="0"/>
           </a:p>
         </p:txBody>
       </p:sp>
@@ -5444,7 +6024,7 @@
                 <a:ea typeface="Calibri" pitchFamily="34" charset="-122"/>
                 <a:cs typeface="Calibri" pitchFamily="34" charset="-120"/>
               </a:rPr>
-              <a:t>OMP scales with N, reaching 6x at 1m. MPI v2 holds steady around 5x across all sizes.
+              <a:t>OMP, MPI, and Hybrid improve performance as N increases.
 </a:t>
             </a:r>
             <a:r>
@@ -5467,7 +6047,7 @@
                 <a:ea typeface="Calibri" pitchFamily="34" charset="-122"/>
                 <a:cs typeface="Calibri" pitchFamily="34" charset="-120"/>
               </a:rPr>
-              <a:t>OMP and MPI v2 both improve with N. MPI now competitive with OMP.</a:t>
+              <a:t>Performance increases initially then decreases as N increases.</a:t>
             </a:r>
             <a:endParaRPr lang="en-US" sz="1600" dirty="0"/>
           </a:p>
@@ -5478,7 +6058,7 @@
           <p:cNvPr id="8" name="Picture 7">
             <a:extLst>
               <a:ext uri="{FF2B5EF4-FFF2-40B4-BE49-F238E27FC236}">
-                <a16:creationId xmlns:a16="http://schemas.microsoft.com/office/drawing/2014/main" id="{C2417921-B87D-1463-BEA4-B2F6BE87ED1C}"/>
+                <a16:creationId xmlns:a16="http://schemas.microsoft.com/office/drawing/2014/main" id="{88C5AA48-6CB4-FC70-7292-9F25A73D566F}"/>
               </a:ext>
             </a:extLst>
           </p:cNvPr>
@@ -5495,8 +6075,8 @@
         </p:blipFill>
         <p:spPr>
           <a:xfrm>
-            <a:off x="1543359" y="2106006"/>
-            <a:ext cx="6057282" cy="3017520"/>
+            <a:off x="1387737" y="2100432"/>
+            <a:ext cx="6060994" cy="3017520"/>
           </a:xfrm>
           <a:prstGeom prst="rect">
             <a:avLst/>
@@ -5677,7 +6257,7 @@
                 <a:ea typeface="Calibri" pitchFamily="34" charset="-122"/>
                 <a:cs typeface="Calibri" pitchFamily="34" charset="-120"/>
               </a:rPr>
-              <a:t>OMP leads at 9.11x. MPI v2 reaches 6.30x. Hybrid peaks at 8.06x.
+              <a:t>OMP leads at 8.41x. MPI v2 reaches 6.55x. Hybrid peaks at 8.06x.
 </a:t>
             </a:r>
             <a:r>
@@ -5700,7 +6280,7 @@
                 <a:ea typeface="Calibri" pitchFamily="34" charset="-122"/>
                 <a:cs typeface="Calibri" pitchFamily="34" charset="-120"/>
               </a:rPr>
-              <a:t>OMP leads at 3.62x. MPI v2 reaches 2.98x. Hybrid peaks at 3.48x.</a:t>
+              <a:t>OMP leads at 3.29x. MPI v2 reaches 2.67x. Hybrid peaks at 3.13x.</a:t>
             </a:r>
             <a:endParaRPr lang="en-US" sz="1600" dirty="0"/>
           </a:p>
@@ -5708,10 +6288,10 @@
       </p:sp>
       <p:pic>
         <p:nvPicPr>
-          <p:cNvPr id="8" name="Picture 7">
+          <p:cNvPr id="10" name="Picture 9">
             <a:extLst>
               <a:ext uri="{FF2B5EF4-FFF2-40B4-BE49-F238E27FC236}">
-                <a16:creationId xmlns:a16="http://schemas.microsoft.com/office/drawing/2014/main" id="{591D2A93-C132-774C-24E3-8E4C73C2DC2C}"/>
+                <a16:creationId xmlns:a16="http://schemas.microsoft.com/office/drawing/2014/main" id="{8978B677-D81D-C778-2E62-0DAE6A7DFC1F}"/>
               </a:ext>
             </a:extLst>
           </p:cNvPr>
@@ -5728,7 +6308,7 @@
         </p:blipFill>
         <p:spPr>
           <a:xfrm>
-            <a:off x="834390" y="2106006"/>
+            <a:off x="834390" y="2100432"/>
             <a:ext cx="7475219" cy="3017520"/>
           </a:xfrm>
           <a:prstGeom prst="rect">
@@ -6058,9 +6638,50 @@
                 <a:ea typeface="Calibri" pitchFamily="34" charset="-122"/>
                 <a:cs typeface="Calibri" pitchFamily="34" charset="-120"/>
               </a:rPr>
-              <a:t>OMP scaled well on both systems  design paid off
-MPI v1 bottlenecked by copy_rows; v2 fixed it and scaled to 6.30x on Expanse
+              <a:t>OMP scaled well on both systems:  design paid off
+MPI v1 bottlenecked by </a:t>
+            </a:r>
+            <a:r>
+              <a:rPr lang="en-US" sz="1400" dirty="0" err="1">
+                <a:solidFill>
+                  <a:srgbClr val="1A1A1A"/>
+                </a:solidFill>
+                <a:latin typeface="Calibri" pitchFamily="34" charset="0"/>
+                <a:ea typeface="Calibri" pitchFamily="34" charset="-122"/>
+                <a:cs typeface="Calibri" pitchFamily="34" charset="-120"/>
+              </a:rPr>
+              <a:t>copy_rows</a:t>
+            </a:r>
+            <a:r>
+              <a:rPr lang="en-US" sz="1400" dirty="0">
+                <a:solidFill>
+                  <a:srgbClr val="1A1A1A"/>
+                </a:solidFill>
+                <a:latin typeface="Calibri" pitchFamily="34" charset="0"/>
+                <a:ea typeface="Calibri" pitchFamily="34" charset="-122"/>
+                <a:cs typeface="Calibri" pitchFamily="34" charset="-120"/>
+              </a:rPr>
+              <a:t>, v2 fixed it and scaled to 6.55x on Expanse
 Hybrid v2 reached 8.06x combining both levels of parallelism</a:t>
+            </a:r>
+          </a:p>
+          <a:p>
+            <a:pPr marL="0" indent="0">
+              <a:spcAft>
+                <a:spcPts val="400"/>
+              </a:spcAft>
+              <a:buNone/>
+            </a:pPr>
+            <a:r>
+              <a:rPr lang="en-US" sz="1400" dirty="0">
+                <a:solidFill>
+                  <a:srgbClr val="1A1A1A"/>
+                </a:solidFill>
+                <a:latin typeface="Calibri" pitchFamily="34" charset="0"/>
+                <a:ea typeface="Calibri" pitchFamily="34" charset="-122"/>
+                <a:cs typeface="Calibri" pitchFamily="34" charset="-120"/>
+              </a:rPr>
+              <a:t>Both MPI and Hybrid under performed vs OMP</a:t>
             </a:r>
             <a:endParaRPr lang="en-US" sz="1400" dirty="0"/>
           </a:p>
@@ -6096,7 +6717,7 @@
           <a:bodyPr/>
           <a:lstStyle/>
           <a:p>
-            <a:endParaRPr lang="en-US"/>
+            <a:endParaRPr lang="en-US" dirty="0"/>
           </a:p>
         </p:txBody>
       </p:sp>
@@ -6160,12 +6781,22 @@
           <a:bodyPr wrap="square" rtlCol="0" anchor="t"/>
           <a:lstStyle/>
           <a:p>
-            <a:pPr marL="0" indent="0">
-              <a:spcAft>
-                <a:spcPts val="400"/>
-              </a:spcAft>
-              <a:buNone/>
-            </a:pPr>
+            <a:r>
+              <a:rPr lang="en-US" sz="1400" dirty="0"/>
+              <a:t>Allocated 4 nodes × 16 tasks × 8 CPUs to fully utilize 128 cores per node</a:t>
+            </a:r>
+          </a:p>
+          <a:p>
+            <a:r>
+              <a:rPr lang="en-US" sz="1400" dirty="0"/>
+              <a:t>--bind-to none untethered threads from specific cores but all 16 threads still run within their rank 16 threads per rank exceeded the 8-CPU ceiling; more nodes cannot fix intra-rank oversubscription</a:t>
+            </a:r>
+          </a:p>
+          <a:p>
+            <a:r>
+              <a:rPr lang="en-US" sz="1400" dirty="0"/>
+              <a:t>Collapse to 0.628x below serial is the expected result of 2:1 thread oversubscription </a:t>
+            </a:r>
             <a:r>
               <a:rPr lang="en-US" sz="1400" dirty="0">
                 <a:solidFill>
@@ -6175,31 +6806,8 @@
                 <a:ea typeface="Calibri" pitchFamily="34" charset="-122"/>
                 <a:cs typeface="Calibri" pitchFamily="34" charset="-120"/>
               </a:rPr>
-              <a:t>--ntasks-per-node=128 in the script (and </a:t>
-            </a:r>
-            <a:r>
-              <a:rPr lang="en-US" sz="1400" dirty="0" err="1">
-                <a:solidFill>
-                  <a:srgbClr val="1A1A1A"/>
-                </a:solidFill>
-                <a:latin typeface="Calibri" pitchFamily="34" charset="0"/>
-                <a:ea typeface="Calibri" pitchFamily="34" charset="-122"/>
-                <a:cs typeface="Calibri" pitchFamily="34" charset="-120"/>
-              </a:rPr>
-              <a:t>expance</a:t>
-            </a:r>
-            <a:r>
-              <a:rPr lang="en-US" sz="1400" dirty="0">
-                <a:solidFill>
-                  <a:srgbClr val="1A1A1A"/>
-                </a:solidFill>
-                <a:latin typeface="Calibri" pitchFamily="34" charset="0"/>
-                <a:ea typeface="Calibri" pitchFamily="34" charset="-122"/>
-                <a:cs typeface="Calibri" pitchFamily="34" charset="-120"/>
-              </a:rPr>
-              <a:t> limit per node) set the core limit; at 16p x 16t we hit exactly 256 workers on 128 cores
-MPI coordination overhead on top pushed performance below serial
-Multi-node MPI runs would be the natural next step to scale further</a:t>
+              <a:t>
+</a:t>
             </a:r>
             <a:endParaRPr lang="en-US" sz="1400" dirty="0"/>
           </a:p>
@@ -6299,6 +6907,35 @@
           <a:bodyPr wrap="square" rtlCol="0" anchor="t"/>
           <a:lstStyle/>
           <a:p>
+            <a:pPr>
+              <a:spcAft>
+                <a:spcPts val="400"/>
+              </a:spcAft>
+            </a:pPr>
+            <a:r>
+              <a:rPr lang="en-US" sz="1400" dirty="0"/>
+              <a:t>MPI scaling on the Linux cluster was modest, reaching only 2.67x at 8 procs</a:t>
+            </a:r>
+          </a:p>
+          <a:p>
+            <a:pPr>
+              <a:spcAft>
+                <a:spcPts val="400"/>
+              </a:spcAft>
+            </a:pPr>
+            <a:r>
+              <a:rPr lang="en-US" sz="1400" dirty="0">
+                <a:solidFill>
+                  <a:srgbClr val="1A1A1A"/>
+                </a:solidFill>
+                <a:latin typeface="Calibri" pitchFamily="34" charset="0"/>
+                <a:ea typeface="Calibri" pitchFamily="34" charset="-122"/>
+                <a:cs typeface="Calibri" pitchFamily="34" charset="-120"/>
+              </a:rPr>
+              <a:t>Hybrid peaked at 3.13x (2p×8t): oversubscription degraded performance beyond 4 procs</a:t>
+            </a:r>
+          </a:p>
+          <a:p>
             <a:pPr marL="0" indent="0">
               <a:spcAft>
                 <a:spcPts val="400"/>
@@ -6314,9 +6951,7 @@
                 <a:ea typeface="Calibri" pitchFamily="34" charset="-122"/>
                 <a:cs typeface="Calibri" pitchFamily="34" charset="-120"/>
               </a:rPr>
-              <a:t>Capped at 8 procs/threads in the bash script
---oversubscribe flag used for hybrid runs; performance degraded early, suggesting fewer than 32 physical cores
-Adding processes beyond 4 consistently hurt performance</a:t>
+              <a:t>Neither parallelization strategy gains much from larger data, suggesting memory bandwidth limits</a:t>
             </a:r>
             <a:endParaRPr lang="en-US" sz="1400" dirty="0"/>
           </a:p>
@@ -10415,7 +11050,7 @@
                 <a:ea typeface="Calibri" pitchFamily="34" charset="-122"/>
                 <a:cs typeface="Calibri" pitchFamily="34" charset="-120"/>
               </a:rPr>
-              <a:t>schedule(static)</a:t>
+              <a:t>schedule(static default)</a:t>
             </a:r>
             <a:r>
               <a:rPr lang="en-US" sz="1400" dirty="0">
@@ -10499,7 +11134,7 @@
                 <a:ea typeface="Calibri" pitchFamily="34" charset="-122"/>
                 <a:cs typeface="Calibri" pitchFamily="34" charset="-120"/>
               </a:rPr>
-              <a:t>Serial design enabled this — row ranges, flat arrays, and read-only log_probs required minimal changes.</a:t>
+              <a:t>Serial design enabled this, row ranges, flat arrays, and read-only log_probs required minimal changes.</a:t>
             </a:r>
             <a:endParaRPr lang="en-US" sz="1300" dirty="0"/>
           </a:p>
@@ -10569,7 +11204,7 @@
               <a:buNone/>
             </a:pPr>
             <a:r>
-              <a:rPr lang="en-US" sz="1200" i="1" dirty="0">
+              <a:rPr lang="en-US" sz="1400" i="1" dirty="0">
                 <a:solidFill>
                   <a:srgbClr val="888888"/>
                 </a:solidFill>
@@ -10577,9 +11212,9 @@
                 <a:ea typeface="Calibri" pitchFamily="34" charset="-122"/>
                 <a:cs typeface="Calibri" pitchFamily="34" charset="-120"/>
               </a:rPr>
-              <a:t>Count accumulation — array reduction</a:t>
-            </a:r>
-            <a:endParaRPr lang="en-US" sz="1200" dirty="0"/>
+              <a:t>Count accumulation  array reduction</a:t>
+            </a:r>
+            <a:endParaRPr lang="en-US" sz="1400" dirty="0"/>
           </a:p>
         </p:txBody>
       </p:sp>
@@ -10650,74 +11285,63 @@
                 <a:ea typeface="Courier New" pitchFamily="34" charset="-122"/>
                 <a:cs typeface="Courier New" pitchFamily="34" charset="-120"/>
               </a:rPr>
-              <a:t>#pragma omp parallel for </a:t>
+              <a:t>#pragma omp parallel for</a:t>
             </a:r>
             <a:r>
               <a:rPr lang="en-US" sz="1100" dirty="0">
                 <a:solidFill>
-                  <a:srgbClr val="FDE68A"/>
+                  <a:srgbClr val="FFFFFF"/>
                 </a:solidFill>
                 <a:latin typeface="Courier New" pitchFamily="34" charset="0"/>
                 <a:ea typeface="Courier New" pitchFamily="34" charset="-122"/>
                 <a:cs typeface="Courier New" pitchFamily="34" charset="-120"/>
               </a:rPr>
-              <a:t>schedule</a:t>
+              <a:t>
+</a:t>
             </a:r>
             <a:r>
               <a:rPr lang="en-US" sz="1100" dirty="0">
                 <a:solidFill>
-                  <a:srgbClr val="FFFFFF"/>
+                  <a:srgbClr val="FDE68A"/>
                 </a:solidFill>
                 <a:latin typeface="Courier New" pitchFamily="34" charset="0"/>
                 <a:ea typeface="Courier New" pitchFamily="34" charset="-122"/>
                 <a:cs typeface="Courier New" pitchFamily="34" charset="-120"/>
               </a:rPr>
-              <a:t>(static) \
-</a:t>
+              <a:t>  reduction</a:t>
             </a:r>
             <a:r>
               <a:rPr lang="en-US" sz="1100" dirty="0">
                 <a:solidFill>
-                  <a:srgbClr val="FDE68A"/>
+                  <a:srgbClr val="FFFFFF"/>
                 </a:solidFill>
                 <a:latin typeface="Courier New" pitchFamily="34" charset="0"/>
                 <a:ea typeface="Courier New" pitchFamily="34" charset="-122"/>
                 <a:cs typeface="Courier New" pitchFamily="34" charset="-120"/>
               </a:rPr>
-              <a:t>  reduction</a:t>
+              <a:t>(+:class_counts[:C]) \
+</a:t>
             </a:r>
             <a:r>
               <a:rPr lang="en-US" sz="1100" dirty="0">
                 <a:solidFill>
-                  <a:srgbClr val="FFFFFF"/>
+                  <a:srgbClr val="FDE68A"/>
                 </a:solidFill>
                 <a:latin typeface="Courier New" pitchFamily="34" charset="0"/>
                 <a:ea typeface="Courier New" pitchFamily="34" charset="-122"/>
                 <a:cs typeface="Courier New" pitchFamily="34" charset="-120"/>
               </a:rPr>
-              <a:t>(+:class_counts[:C]) \
-</a:t>
+              <a:t>  reduction</a:t>
             </a:r>
             <a:r>
               <a:rPr lang="en-US" sz="1100" dirty="0">
                 <a:solidFill>
-                  <a:srgbClr val="FDE68A"/>
+                  <a:srgbClr val="FFFFFF"/>
                 </a:solidFill>
                 <a:latin typeface="Courier New" pitchFamily="34" charset="0"/>
                 <a:ea typeface="Courier New" pitchFamily="34" charset="-122"/>
                 <a:cs typeface="Courier New" pitchFamily="34" charset="-120"/>
               </a:rPr>
-              <a:t>  reduction</a:t>
-            </a:r>
-            <a:r>
-              <a:rPr lang="en-US" sz="1100" dirty="0">
-                <a:solidFill>
-                  <a:srgbClr val="FFFFFF"/>
-                </a:solidFill>
-                <a:latin typeface="Courier New" pitchFamily="34" charset="0"/>
-                <a:ea typeface="Courier New" pitchFamily="34" charset="-122"/>
-                <a:cs typeface="Courier New" pitchFamily="34" charset="-120"/>
-              </a:rPr>
               <a:t>(+:feature_counts[:P])</a:t>
             </a:r>
             <a:endParaRPr lang="en-US" sz="1100" dirty="0"/>
@@ -10749,7 +11373,7 @@
               <a:buNone/>
             </a:pPr>
             <a:r>
-              <a:rPr lang="en-US" sz="1200" i="1" dirty="0">
+              <a:rPr lang="en-US" sz="1400" i="1" dirty="0">
                 <a:solidFill>
                   <a:srgbClr val="888888"/>
                 </a:solidFill>
@@ -10757,9 +11381,9 @@
                 <a:ea typeface="Calibri" pitchFamily="34" charset="-122"/>
                 <a:cs typeface="Calibri" pitchFamily="34" charset="-120"/>
               </a:rPr>
-              <a:t>Classification — embarrassingly parallel</a:t>
-            </a:r>
-            <a:endParaRPr lang="en-US" sz="1200" dirty="0"/>
+              <a:t>Classification</a:t>
+            </a:r>
+            <a:endParaRPr lang="en-US" sz="1400" dirty="0"/>
           </a:p>
         </p:txBody>
       </p:sp>
@@ -10907,7 +11531,7 @@
               <a:buNone/>
             </a:pPr>
             <a:r>
-              <a:rPr lang="en-US" sz="1200" i="1" dirty="0">
+              <a:rPr lang="en-US" sz="1400" i="1" dirty="0">
                 <a:solidFill>
                   <a:srgbClr val="888888"/>
                 </a:solidFill>
@@ -10915,9 +11539,9 @@
                 <a:ea typeface="Calibri" pitchFamily="34" charset="-122"/>
                 <a:cs typeface="Calibri" pitchFamily="34" charset="-120"/>
               </a:rPr>
-              <a:t>Accuracy — scalar reduction</a:t>
-            </a:r>
-            <a:endParaRPr lang="en-US" sz="1200" dirty="0"/>
+              <a:t>Accuracy reduction</a:t>
+            </a:r>
+            <a:endParaRPr lang="en-US" sz="1400" dirty="0"/>
           </a:p>
         </p:txBody>
       </p:sp>
@@ -11465,7 +12089,7 @@
               <a:buNone/>
             </a:pPr>
             <a:r>
-              <a:rPr lang="en-US" sz="1200" i="1" dirty="0" err="1">
+              <a:rPr lang="en-US" sz="1400" i="1" dirty="0" err="1">
                 <a:solidFill>
                   <a:srgbClr val="888888"/>
                 </a:solidFill>
@@ -11475,18 +12099,7 @@
               </a:rPr>
               <a:t>copy_rows</a:t>
             </a:r>
-            <a:r>
-              <a:rPr lang="en-US" sz="1200" i="1" dirty="0">
-                <a:solidFill>
-                  <a:srgbClr val="888888"/>
-                </a:solidFill>
-                <a:latin typeface="Calibri" pitchFamily="34" charset="0"/>
-                <a:ea typeface="Calibri" pitchFamily="34" charset="-122"/>
-                <a:cs typeface="Calibri" pitchFamily="34" charset="-120"/>
-              </a:rPr>
-              <a:t>  called twice per fold across 5 folds</a:t>
-            </a:r>
-            <a:endParaRPr lang="en-US" sz="1200" dirty="0"/>
+            <a:endParaRPr lang="en-US" sz="1400" dirty="0"/>
           </a:p>
         </p:txBody>
       </p:sp>
@@ -11499,7 +12112,7 @@
         <p:spPr>
           <a:xfrm>
             <a:off x="4846320" y="1389888"/>
-            <a:ext cx="4023360" cy="1097280"/>
+            <a:ext cx="4023360" cy="1188720"/>
           </a:xfrm>
           <a:prstGeom prst="roundRect">
             <a:avLst>
@@ -11674,7 +12287,7 @@
         </p:nvSpPr>
         <p:spPr>
           <a:xfrm>
-            <a:off x="4846320" y="2578608"/>
+            <a:off x="4846320" y="2635758"/>
             <a:ext cx="4023360" cy="201168"/>
           </a:xfrm>
           <a:prstGeom prst="rect">
@@ -11691,7 +12304,7 @@
               <a:buNone/>
             </a:pPr>
             <a:r>
-              <a:rPr lang="en-US" sz="1200" i="1" dirty="0" err="1">
+              <a:rPr lang="en-US" sz="1400" i="1" dirty="0" err="1">
                 <a:solidFill>
                   <a:srgbClr val="888888"/>
                 </a:solidFill>
@@ -11701,18 +12314,7 @@
               </a:rPr>
               <a:t>confusion_matrix_binary</a:t>
             </a:r>
-            <a:r>
-              <a:rPr lang="en-US" sz="1200" i="1" dirty="0">
-                <a:solidFill>
-                  <a:srgbClr val="888888"/>
-                </a:solidFill>
-                <a:latin typeface="Calibri" pitchFamily="34" charset="0"/>
-                <a:ea typeface="Calibri" pitchFamily="34" charset="-122"/>
-                <a:cs typeface="Calibri" pitchFamily="34" charset="-120"/>
-              </a:rPr>
-              <a:t>  count locally, reduce to rank 0</a:t>
-            </a:r>
-            <a:endParaRPr lang="en-US" sz="1200" dirty="0"/>
+            <a:endParaRPr lang="en-US" sz="1400" dirty="0"/>
           </a:p>
         </p:txBody>
       </p:sp>
@@ -11724,8 +12326,8 @@
         </p:nvSpPr>
         <p:spPr>
           <a:xfrm>
-            <a:off x="4846320" y="2807208"/>
-            <a:ext cx="4023360" cy="2011680"/>
+            <a:off x="4846320" y="2864358"/>
+            <a:ext cx="4023360" cy="2103120"/>
           </a:xfrm>
           <a:prstGeom prst="roundRect">
             <a:avLst>
@@ -11758,7 +12360,7 @@
         </p:nvSpPr>
         <p:spPr>
           <a:xfrm>
-            <a:off x="4983480" y="2807208"/>
+            <a:off x="4983480" y="2864358"/>
             <a:ext cx="3749040" cy="2011680"/>
           </a:xfrm>
           <a:prstGeom prst="rect">
@@ -12378,8 +12980,8 @@
         </p:nvSpPr>
         <p:spPr>
           <a:xfrm>
-            <a:off x="4812545" y="1173234"/>
-            <a:ext cx="4114800" cy="3520440"/>
+            <a:off x="4812545" y="1144658"/>
+            <a:ext cx="4114800" cy="3846441"/>
           </a:xfrm>
           <a:prstGeom prst="roundRect">
             <a:avLst>
@@ -12412,7 +13014,7 @@
         </p:nvSpPr>
         <p:spPr>
           <a:xfrm>
-            <a:off x="4892040" y="1173234"/>
+            <a:off x="4892040" y="1307658"/>
             <a:ext cx="3840480" cy="3520440"/>
           </a:xfrm>
           <a:prstGeom prst="rect">
@@ -12429,7 +13031,7 @@
               <a:buNone/>
             </a:pPr>
             <a:r>
-              <a:rPr lang="en-US" sz="1050" dirty="0">
+              <a:rPr lang="en-US" sz="1100" dirty="0">
                 <a:solidFill>
                   <a:srgbClr val="888888"/>
                 </a:solidFill>
@@ -12441,7 +13043,7 @@
 </a:t>
             </a:r>
             <a:r>
-              <a:rPr lang="en-US" sz="1050" dirty="0">
+              <a:rPr lang="en-US" sz="1100" dirty="0">
                 <a:solidFill>
                   <a:srgbClr val="7DD3FC"/>
                 </a:solidFill>
@@ -12452,7 +13054,7 @@
               <a:t>MPI_Comm_rank</a:t>
             </a:r>
             <a:r>
-              <a:rPr lang="en-US" sz="1050" dirty="0">
+              <a:rPr lang="en-US" sz="1100" dirty="0">
                 <a:solidFill>
                   <a:srgbClr val="FFFFFF"/>
                 </a:solidFill>
@@ -12464,7 +13066,7 @@
 </a:t>
             </a:r>
             <a:r>
-              <a:rPr lang="en-US" sz="1050" dirty="0">
+              <a:rPr lang="en-US" sz="1100" dirty="0">
                 <a:solidFill>
                   <a:srgbClr val="FDE68A"/>
                 </a:solidFill>
@@ -12475,7 +13077,7 @@
               <a:t>int </a:t>
             </a:r>
             <a:r>
-              <a:rPr lang="en-US" sz="1050" dirty="0">
+              <a:rPr lang="en-US" sz="1100" dirty="0">
                 <a:solidFill>
                   <a:srgbClr val="FFFFFF"/>
                 </a:solidFill>
@@ -12487,7 +13089,7 @@
 </a:t>
             </a:r>
             <a:r>
-              <a:rPr lang="en-US" sz="1050" dirty="0">
+              <a:rPr lang="en-US" sz="1100" dirty="0">
                 <a:solidFill>
                   <a:srgbClr val="FDE68A"/>
                 </a:solidFill>
@@ -12498,7 +13100,7 @@
               <a:t>int </a:t>
             </a:r>
             <a:r>
-              <a:rPr lang="en-US" sz="1050" dirty="0">
+              <a:rPr lang="en-US" sz="1100" dirty="0">
                 <a:solidFill>
                   <a:srgbClr val="FFFFFF"/>
                 </a:solidFill>
@@ -12510,7 +13112,7 @@
 </a:t>
             </a:r>
             <a:r>
-              <a:rPr lang="en-US" sz="1050" dirty="0">
+              <a:rPr lang="en-US" sz="1100" dirty="0">
                 <a:solidFill>
                   <a:srgbClr val="888888"/>
                 </a:solidFill>
@@ -12522,7 +13124,7 @@
 </a:t>
             </a:r>
             <a:r>
-              <a:rPr lang="en-US" sz="1050" dirty="0">
+              <a:rPr lang="en-US" sz="1100" dirty="0">
                 <a:solidFill>
                   <a:srgbClr val="C4B5FD"/>
                 </a:solidFill>
@@ -12533,7 +13135,7 @@
               <a:t>#pragma omp parallel for </a:t>
             </a:r>
             <a:r>
-              <a:rPr lang="en-US" sz="1050" dirty="0">
+              <a:rPr lang="en-US" sz="1100" dirty="0">
                 <a:solidFill>
                   <a:srgbClr val="FDE68A"/>
                 </a:solidFill>
@@ -12544,7 +13146,7 @@
               <a:t>schedule</a:t>
             </a:r>
             <a:r>
-              <a:rPr lang="en-US" sz="1050" dirty="0">
+              <a:rPr lang="en-US" sz="1100" dirty="0">
                 <a:solidFill>
                   <a:srgbClr val="FFFFFF"/>
                 </a:solidFill>
@@ -12556,7 +13158,7 @@
 </a:t>
             </a:r>
             <a:r>
-              <a:rPr lang="en-US" sz="1050" dirty="0">
+              <a:rPr lang="en-US" sz="1100" dirty="0">
                 <a:solidFill>
                   <a:srgbClr val="FDE68A"/>
                 </a:solidFill>
@@ -12567,7 +13169,7 @@
               <a:t>  reduction</a:t>
             </a:r>
             <a:r>
-              <a:rPr lang="en-US" sz="1050" dirty="0">
+              <a:rPr lang="en-US" sz="1100" dirty="0">
                 <a:solidFill>
                   <a:srgbClr val="FFFFFF"/>
                 </a:solidFill>
@@ -12579,7 +13181,7 @@
 </a:t>
             </a:r>
             <a:r>
-              <a:rPr lang="en-US" sz="1050" dirty="0">
+              <a:rPr lang="en-US" sz="1100" dirty="0">
                 <a:solidFill>
                   <a:srgbClr val="FDE68A"/>
                 </a:solidFill>
@@ -12590,7 +13192,7 @@
               <a:t>  reduction</a:t>
             </a:r>
             <a:r>
-              <a:rPr lang="en-US" sz="1050" dirty="0">
+              <a:rPr lang="en-US" sz="1100" dirty="0">
                 <a:solidFill>
                   <a:srgbClr val="FFFFFF"/>
                 </a:solidFill>
@@ -12602,7 +13204,7 @@
 </a:t>
             </a:r>
             <a:r>
-              <a:rPr lang="en-US" sz="1050" dirty="0">
+              <a:rPr lang="en-US" sz="1100" dirty="0">
                 <a:solidFill>
                   <a:srgbClr val="FDE68A"/>
                 </a:solidFill>
@@ -12613,7 +13215,7 @@
               <a:t>for </a:t>
             </a:r>
             <a:r>
-              <a:rPr lang="en-US" sz="1050" dirty="0">
+              <a:rPr lang="en-US" sz="1100" dirty="0">
                 <a:solidFill>
                   <a:srgbClr val="FFFFFF"/>
                 </a:solidFill>
@@ -12625,7 +13227,7 @@
 </a:t>
             </a:r>
             <a:r>
-              <a:rPr lang="en-US" sz="1050" dirty="0">
+              <a:rPr lang="en-US" sz="1100" dirty="0">
                 <a:solidFill>
                   <a:srgbClr val="888888"/>
                 </a:solidFill>
@@ -12639,7 +13241,7 @@
 </a:t>
             </a:r>
             <a:r>
-              <a:rPr lang="en-US" sz="1050" dirty="0">
+              <a:rPr lang="en-US" sz="1100" dirty="0">
                 <a:solidFill>
                   <a:srgbClr val="FCA5A5"/>
                 </a:solidFill>
@@ -12650,7 +13252,7 @@
               <a:t>MPI_Allreduce</a:t>
             </a:r>
             <a:r>
-              <a:rPr lang="en-US" sz="1050" dirty="0">
+              <a:rPr lang="en-US" sz="1100" dirty="0">
                 <a:solidFill>
                   <a:srgbClr val="FFFFFF"/>
                 </a:solidFill>
@@ -12663,7 +13265,7 @@
 </a:t>
             </a:r>
             <a:r>
-              <a:rPr lang="en-US" sz="1050" dirty="0">
+              <a:rPr lang="en-US" sz="1100" dirty="0">
                 <a:solidFill>
                   <a:srgbClr val="FCA5A5"/>
                 </a:solidFill>
@@ -12674,7 +13276,7 @@
               <a:t>MPI_Allreduce</a:t>
             </a:r>
             <a:r>
-              <a:rPr lang="en-US" sz="1050" dirty="0">
+              <a:rPr lang="en-US" sz="1100" dirty="0">
                 <a:solidFill>
                   <a:srgbClr val="FFFFFF"/>
                 </a:solidFill>
@@ -12684,14 +13286,14 @@
               </a:rPr>
               <a:t>(local_feat, feature_counts,</a:t>
             </a:r>
-            <a:endParaRPr lang="en-US" sz="1050" dirty="0"/>
+            <a:endParaRPr lang="en-US" sz="1100" dirty="0"/>
           </a:p>
           <a:p>
             <a:pPr marL="0" indent="0">
               <a:buNone/>
             </a:pPr>
             <a:r>
-              <a:rPr lang="en-US" sz="1050" dirty="0">
+              <a:rPr lang="en-US" sz="1100" dirty="0">
                 <a:solidFill>
                   <a:srgbClr val="FFFFFF"/>
                 </a:solidFill>
@@ -12701,7 +13303,7 @@
               </a:rPr>
               <a:t>  P, MPI_LONG_LONG, MPI_SUM, WORLD);</a:t>
             </a:r>
-            <a:endParaRPr lang="en-US" sz="1050" dirty="0"/>
+            <a:endParaRPr lang="en-US" sz="1100" dirty="0"/>
           </a:p>
         </p:txBody>
       </p:sp>
@@ -12827,7 +13429,7 @@
               <a:buChar char="•"/>
             </a:pPr>
             <a:r>
-              <a:rPr lang="en-US" sz="1600" dirty="0">
+              <a:rPr lang="en-US" dirty="0">
                 <a:solidFill>
                   <a:srgbClr val="1A1A1A"/>
                 </a:solidFill>
@@ -12845,7 +13447,7 @@
               <a:buChar char="•"/>
             </a:pPr>
             <a:r>
-              <a:rPr lang="en-US" sz="1600" dirty="0">
+              <a:rPr lang="en-US" dirty="0">
                 <a:solidFill>
                   <a:srgbClr val="1A1A1A"/>
                 </a:solidFill>
@@ -12855,7 +13457,7 @@
               </a:rPr>
               <a:t>Performance phase: each configuration run 5 times and averaged</a:t>
             </a:r>
-            <a:endParaRPr lang="en-US" sz="1600" dirty="0"/>
+            <a:endParaRPr lang="en-US" dirty="0"/>
           </a:p>
           <a:p>
             <a:pPr marL="342900" indent="-342900">
@@ -12874,7 +13476,7 @@
         </p:nvSpPr>
         <p:spPr>
           <a:xfrm>
-            <a:off x="228600" y="2060047"/>
+            <a:off x="228600" y="1945747"/>
             <a:ext cx="4114800" cy="228600"/>
           </a:xfrm>
           <a:prstGeom prst="rect">
@@ -12914,13 +13516,13 @@
           <p:nvPr>
             <p:extLst>
               <p:ext uri="{D42A27DB-BD31-4B8C-83A1-F6EECF244321}">
-                <p14:modId xmlns:p14="http://schemas.microsoft.com/office/powerpoint/2010/main" val="3743117273"/>
+                <p14:modId xmlns:p14="http://schemas.microsoft.com/office/powerpoint/2010/main" val="2804466758"/>
               </p:ext>
             </p:extLst>
           </p:nvPr>
         </p:nvGraphicFramePr>
         <p:xfrm>
-          <a:off x="228600" y="2316079"/>
+          <a:off x="228600" y="2201779"/>
           <a:ext cx="4114800" cy="2468880"/>
         </p:xfrm>
         <a:graphic>
@@ -13611,7 +14213,7 @@
         </p:nvSpPr>
         <p:spPr>
           <a:xfrm>
-            <a:off x="4800600" y="2060047"/>
+            <a:off x="4800600" y="1945747"/>
             <a:ext cx="4114800" cy="228600"/>
           </a:xfrm>
           <a:prstGeom prst="rect">
@@ -13651,13 +14253,13 @@
           <p:nvPr>
             <p:extLst>
               <p:ext uri="{D42A27DB-BD31-4B8C-83A1-F6EECF244321}">
-                <p14:modId xmlns:p14="http://schemas.microsoft.com/office/powerpoint/2010/main" val="1191545498"/>
+                <p14:modId xmlns:p14="http://schemas.microsoft.com/office/powerpoint/2010/main" val="3429568789"/>
               </p:ext>
             </p:extLst>
           </p:nvPr>
         </p:nvGraphicFramePr>
         <p:xfrm>
-          <a:off x="4800600" y="2316079"/>
+          <a:off x="4800600" y="2201779"/>
           <a:ext cx="4114800" cy="2468880"/>
         </p:xfrm>
         <a:graphic>

</xml_diff>

<commit_message>
clean up code and comments for submission
</commit_message>
<xml_diff>
--- a/IT388_ParallelNaiveBayes_Final.pptx
+++ b/IT388_ParallelNaiveBayes_Final.pptx
@@ -137,7 +137,7 @@
 <file path=ppt/revisionInfo.xml><?xml version="1.0" encoding="utf-8"?>
 <p1510:revInfo xmlns:a="http://schemas.openxmlformats.org/drawingml/2006/main" xmlns:r="http://schemas.openxmlformats.org/officeDocument/2006/relationships" xmlns:p1510="http://schemas.microsoft.com/office/powerpoint/2015/10/main">
   <p1510:revLst>
-    <p1510:client id="{DA307683-F528-4545-98BE-6884735B25C7}" v="12" dt="2026-04-25T16:12:58.084"/>
+    <p1510:client id="{DA307683-F528-4545-98BE-6884735B25C7}" v="19" dt="2026-04-25T18:50:30.670"/>
   </p1510:revLst>
 </p1510:revInfo>
 </file>
@@ -147,16 +147,24 @@
   <pc:docChgLst>
     <pc:chgData name="Justin Hoffman" userId="40d7c2b8f9dba042" providerId="LiveId" clId="{98AE922D-438C-4FBD-AB6F-EAC5EAC34870}"/>
     <pc:docChg chg="undo custSel modSld">
-      <pc:chgData name="Justin Hoffman" userId="40d7c2b8f9dba042" providerId="LiveId" clId="{98AE922D-438C-4FBD-AB6F-EAC5EAC34870}" dt="2026-04-25T16:13:00.018" v="1132" actId="20577"/>
+      <pc:chgData name="Justin Hoffman" userId="40d7c2b8f9dba042" providerId="LiveId" clId="{98AE922D-438C-4FBD-AB6F-EAC5EAC34870}" dt="2026-04-25T18:56:08.623" v="2165" actId="113"/>
       <pc:docMkLst>
         <pc:docMk/>
       </pc:docMkLst>
       <pc:sldChg chg="modSp mod">
-        <pc:chgData name="Justin Hoffman" userId="40d7c2b8f9dba042" providerId="LiveId" clId="{98AE922D-438C-4FBD-AB6F-EAC5EAC34870}" dt="2026-04-25T06:05:05.540" v="564" actId="255"/>
+        <pc:chgData name="Justin Hoffman" userId="40d7c2b8f9dba042" providerId="LiveId" clId="{98AE922D-438C-4FBD-AB6F-EAC5EAC34870}" dt="2026-04-25T16:20:51.779" v="1140" actId="20577"/>
         <pc:sldMkLst>
           <pc:docMk/>
           <pc:sldMk cId="0" sldId="256"/>
         </pc:sldMkLst>
+        <pc:spChg chg="mod">
+          <ac:chgData name="Justin Hoffman" userId="40d7c2b8f9dba042" providerId="LiveId" clId="{98AE922D-438C-4FBD-AB6F-EAC5EAC34870}" dt="2026-04-25T16:20:51.779" v="1140" actId="20577"/>
+          <ac:spMkLst>
+            <pc:docMk/>
+            <pc:sldMk cId="0" sldId="256"/>
+            <ac:spMk id="3" creationId="{00000000-0000-0000-0000-000000000000}"/>
+          </ac:spMkLst>
+        </pc:spChg>
         <pc:spChg chg="mod">
           <ac:chgData name="Justin Hoffman" userId="40d7c2b8f9dba042" providerId="LiveId" clId="{98AE922D-438C-4FBD-AB6F-EAC5EAC34870}" dt="2026-04-25T06:04:17.782" v="561" actId="255"/>
           <ac:spMkLst>
@@ -210,6 +218,29 @@
             <pc:docMk/>
             <pc:sldMk cId="0" sldId="257"/>
             <ac:spMk id="8" creationId="{00000000-0000-0000-0000-000000000000}"/>
+          </ac:spMkLst>
+        </pc:spChg>
+      </pc:sldChg>
+      <pc:sldChg chg="addSp modSp mod">
+        <pc:chgData name="Justin Hoffman" userId="40d7c2b8f9dba042" providerId="LiveId" clId="{98AE922D-438C-4FBD-AB6F-EAC5EAC34870}" dt="2026-04-25T18:51:06.388" v="2108" actId="1076"/>
+        <pc:sldMkLst>
+          <pc:docMk/>
+          <pc:sldMk cId="0" sldId="259"/>
+        </pc:sldMkLst>
+        <pc:spChg chg="add">
+          <ac:chgData name="Justin Hoffman" userId="40d7c2b8f9dba042" providerId="LiveId" clId="{98AE922D-438C-4FBD-AB6F-EAC5EAC34870}" dt="2026-04-25T18:50:26.962" v="2102"/>
+          <ac:spMkLst>
+            <pc:docMk/>
+            <pc:sldMk cId="0" sldId="259"/>
+            <ac:spMk id="4" creationId="{A18D0721-0E12-1E8B-EFE0-7BB9F9B23878}"/>
+          </ac:spMkLst>
+        </pc:spChg>
+        <pc:spChg chg="mod">
+          <ac:chgData name="Justin Hoffman" userId="40d7c2b8f9dba042" providerId="LiveId" clId="{98AE922D-438C-4FBD-AB6F-EAC5EAC34870}" dt="2026-04-25T18:51:06.388" v="2108" actId="1076"/>
+          <ac:spMkLst>
+            <pc:docMk/>
+            <pc:sldMk cId="0" sldId="259"/>
+            <ac:spMk id="34" creationId="{00000000-0000-0000-0000-000000000000}"/>
           </ac:spMkLst>
         </pc:spChg>
       </pc:sldChg>
@@ -269,13 +300,21 @@
         </pc:spChg>
       </pc:sldChg>
       <pc:sldChg chg="addSp delSp modSp mod">
-        <pc:chgData name="Justin Hoffman" userId="40d7c2b8f9dba042" providerId="LiveId" clId="{98AE922D-438C-4FBD-AB6F-EAC5EAC34870}" dt="2026-04-25T03:22:11.851" v="178" actId="1035"/>
+        <pc:chgData name="Justin Hoffman" userId="40d7c2b8f9dba042" providerId="LiveId" clId="{98AE922D-438C-4FBD-AB6F-EAC5EAC34870}" dt="2026-04-25T18:56:08.623" v="2165" actId="113"/>
         <pc:sldMkLst>
           <pc:docMk/>
           <pc:sldMk cId="0" sldId="262"/>
         </pc:sldMkLst>
+        <pc:spChg chg="mod">
+          <ac:chgData name="Justin Hoffman" userId="40d7c2b8f9dba042" providerId="LiveId" clId="{98AE922D-438C-4FBD-AB6F-EAC5EAC34870}" dt="2026-04-25T18:56:08.623" v="2165" actId="113"/>
+          <ac:spMkLst>
+            <pc:docMk/>
+            <pc:sldMk cId="0" sldId="262"/>
+            <ac:spMk id="5" creationId="{00000000-0000-0000-0000-000000000000}"/>
+          </ac:spMkLst>
+        </pc:spChg>
         <pc:spChg chg="add del mod">
-          <ac:chgData name="Justin Hoffman" userId="40d7c2b8f9dba042" providerId="LiveId" clId="{98AE922D-438C-4FBD-AB6F-EAC5EAC34870}" dt="2026-04-25T03:21:06.043" v="129" actId="20577"/>
+          <ac:chgData name="Justin Hoffman" userId="40d7c2b8f9dba042" providerId="LiveId" clId="{98AE922D-438C-4FBD-AB6F-EAC5EAC34870}" dt="2026-04-25T17:59:35.885" v="1954" actId="20577"/>
           <ac:spMkLst>
             <pc:docMk/>
             <pc:sldMk cId="0" sldId="262"/>
@@ -291,7 +330,7 @@
           </ac:spMkLst>
         </pc:spChg>
         <pc:spChg chg="mod">
-          <ac:chgData name="Justin Hoffman" userId="40d7c2b8f9dba042" providerId="LiveId" clId="{98AE922D-438C-4FBD-AB6F-EAC5EAC34870}" dt="2026-04-25T03:22:11.851" v="178" actId="1035"/>
+          <ac:chgData name="Justin Hoffman" userId="40d7c2b8f9dba042" providerId="LiveId" clId="{98AE922D-438C-4FBD-AB6F-EAC5EAC34870}" dt="2026-04-25T17:59:41.838" v="1964" actId="20577"/>
           <ac:spMkLst>
             <pc:docMk/>
             <pc:sldMk cId="0" sldId="262"/>
@@ -424,12 +463,43 @@
           </ac:picMkLst>
         </pc:picChg>
       </pc:sldChg>
+      <pc:sldChg chg="modSp mod">
+        <pc:chgData name="Justin Hoffman" userId="40d7c2b8f9dba042" providerId="LiveId" clId="{98AE922D-438C-4FBD-AB6F-EAC5EAC34870}" dt="2026-04-25T18:00:58.921" v="1985" actId="20577"/>
+        <pc:sldMkLst>
+          <pc:docMk/>
+          <pc:sldMk cId="0" sldId="266"/>
+        </pc:sldMkLst>
+        <pc:spChg chg="mod">
+          <ac:chgData name="Justin Hoffman" userId="40d7c2b8f9dba042" providerId="LiveId" clId="{98AE922D-438C-4FBD-AB6F-EAC5EAC34870}" dt="2026-04-25T18:00:58.921" v="1985" actId="20577"/>
+          <ac:spMkLst>
+            <pc:docMk/>
+            <pc:sldMk cId="0" sldId="266"/>
+            <ac:spMk id="3" creationId="{00000000-0000-0000-0000-000000000000}"/>
+          </ac:spMkLst>
+        </pc:spChg>
+      </pc:sldChg>
       <pc:sldChg chg="addSp delSp modSp mod">
-        <pc:chgData name="Justin Hoffman" userId="40d7c2b8f9dba042" providerId="LiveId" clId="{98AE922D-438C-4FBD-AB6F-EAC5EAC34870}" dt="2026-04-25T03:25:51.287" v="212" actId="1036"/>
+        <pc:chgData name="Justin Hoffman" userId="40d7c2b8f9dba042" providerId="LiveId" clId="{98AE922D-438C-4FBD-AB6F-EAC5EAC34870}" dt="2026-04-25T18:01:10.052" v="1986" actId="20577"/>
         <pc:sldMkLst>
           <pc:docMk/>
           <pc:sldMk cId="0" sldId="267"/>
         </pc:sldMkLst>
+        <pc:spChg chg="mod">
+          <ac:chgData name="Justin Hoffman" userId="40d7c2b8f9dba042" providerId="LiveId" clId="{98AE922D-438C-4FBD-AB6F-EAC5EAC34870}" dt="2026-04-25T18:01:10.052" v="1986" actId="20577"/>
+          <ac:spMkLst>
+            <pc:docMk/>
+            <pc:sldMk cId="0" sldId="267"/>
+            <ac:spMk id="3" creationId="{00000000-0000-0000-0000-000000000000}"/>
+          </ac:spMkLst>
+        </pc:spChg>
+        <pc:spChg chg="mod">
+          <ac:chgData name="Justin Hoffman" userId="40d7c2b8f9dba042" providerId="LiveId" clId="{98AE922D-438C-4FBD-AB6F-EAC5EAC34870}" dt="2026-04-25T17:49:39.673" v="1363" actId="20577"/>
+          <ac:spMkLst>
+            <pc:docMk/>
+            <pc:sldMk cId="0" sldId="267"/>
+            <ac:spMk id="5" creationId="{00000000-0000-0000-0000-000000000000}"/>
+          </ac:spMkLst>
+        </pc:spChg>
         <pc:picChg chg="add mod">
           <ac:chgData name="Justin Hoffman" userId="40d7c2b8f9dba042" providerId="LiveId" clId="{98AE922D-438C-4FBD-AB6F-EAC5EAC34870}" dt="2026-04-25T03:25:51.287" v="212" actId="1036"/>
           <ac:picMkLst>
@@ -446,6 +516,68 @@
             <ac:picMk id="8" creationId="{203D6C79-AC04-3E12-630F-105467DA58CE}"/>
           </ac:picMkLst>
         </pc:picChg>
+      </pc:sldChg>
+      <pc:sldChg chg="modSp mod">
+        <pc:chgData name="Justin Hoffman" userId="40d7c2b8f9dba042" providerId="LiveId" clId="{98AE922D-438C-4FBD-AB6F-EAC5EAC34870}" dt="2026-04-25T18:09:19.748" v="1991" actId="20577"/>
+        <pc:sldMkLst>
+          <pc:docMk/>
+          <pc:sldMk cId="0" sldId="270"/>
+        </pc:sldMkLst>
+        <pc:spChg chg="mod">
+          <ac:chgData name="Justin Hoffman" userId="40d7c2b8f9dba042" providerId="LiveId" clId="{98AE922D-438C-4FBD-AB6F-EAC5EAC34870}" dt="2026-04-25T17:59:03.275" v="1940" actId="20577"/>
+          <ac:spMkLst>
+            <pc:docMk/>
+            <pc:sldMk cId="0" sldId="270"/>
+            <ac:spMk id="3" creationId="{00000000-0000-0000-0000-000000000000}"/>
+          </ac:spMkLst>
+        </pc:spChg>
+        <pc:spChg chg="mod">
+          <ac:chgData name="Justin Hoffman" userId="40d7c2b8f9dba042" providerId="LiveId" clId="{98AE922D-438C-4FBD-AB6F-EAC5EAC34870}" dt="2026-04-25T17:54:05.354" v="1661" actId="20577"/>
+          <ac:spMkLst>
+            <pc:docMk/>
+            <pc:sldMk cId="0" sldId="270"/>
+            <ac:spMk id="5" creationId="{00000000-0000-0000-0000-000000000000}"/>
+          </ac:spMkLst>
+        </pc:spChg>
+        <pc:spChg chg="mod">
+          <ac:chgData name="Justin Hoffman" userId="40d7c2b8f9dba042" providerId="LiveId" clId="{98AE922D-438C-4FBD-AB6F-EAC5EAC34870}" dt="2026-04-25T18:09:19.748" v="1991" actId="20577"/>
+          <ac:spMkLst>
+            <pc:docMk/>
+            <pc:sldMk cId="0" sldId="270"/>
+            <ac:spMk id="11" creationId="{00000000-0000-0000-0000-000000000000}"/>
+          </ac:spMkLst>
+        </pc:spChg>
+      </pc:sldChg>
+      <pc:sldChg chg="modSp mod">
+        <pc:chgData name="Justin Hoffman" userId="40d7c2b8f9dba042" providerId="LiveId" clId="{98AE922D-438C-4FBD-AB6F-EAC5EAC34870}" dt="2026-04-25T18:10:36.089" v="2045" actId="313"/>
+        <pc:sldMkLst>
+          <pc:docMk/>
+          <pc:sldMk cId="0" sldId="271"/>
+        </pc:sldMkLst>
+        <pc:spChg chg="mod">
+          <ac:chgData name="Justin Hoffman" userId="40d7c2b8f9dba042" providerId="LiveId" clId="{98AE922D-438C-4FBD-AB6F-EAC5EAC34870}" dt="2026-04-25T17:56:53.093" v="1736" actId="1036"/>
+          <ac:spMkLst>
+            <pc:docMk/>
+            <pc:sldMk cId="0" sldId="271"/>
+            <ac:spMk id="5" creationId="{00000000-0000-0000-0000-000000000000}"/>
+          </ac:spMkLst>
+        </pc:spChg>
+        <pc:spChg chg="mod">
+          <ac:chgData name="Justin Hoffman" userId="40d7c2b8f9dba042" providerId="LiveId" clId="{98AE922D-438C-4FBD-AB6F-EAC5EAC34870}" dt="2026-04-25T17:57:36.251" v="1871" actId="20577"/>
+          <ac:spMkLst>
+            <pc:docMk/>
+            <pc:sldMk cId="0" sldId="271"/>
+            <ac:spMk id="7" creationId="{00000000-0000-0000-0000-000000000000}"/>
+          </ac:spMkLst>
+        </pc:spChg>
+        <pc:spChg chg="mod">
+          <ac:chgData name="Justin Hoffman" userId="40d7c2b8f9dba042" providerId="LiveId" clId="{98AE922D-438C-4FBD-AB6F-EAC5EAC34870}" dt="2026-04-25T18:10:36.089" v="2045" actId="313"/>
+          <ac:spMkLst>
+            <pc:docMk/>
+            <pc:sldMk cId="0" sldId="271"/>
+            <ac:spMk id="11" creationId="{00000000-0000-0000-0000-000000000000}"/>
+          </ac:spMkLst>
+        </pc:spChg>
       </pc:sldChg>
       <pc:sldChg chg="addSp delSp modSp mod">
         <pc:chgData name="Justin Hoffman" userId="40d7c2b8f9dba042" providerId="LiveId" clId="{98AE922D-438C-4FBD-AB6F-EAC5EAC34870}" dt="2026-04-25T15:40:23.159" v="611" actId="20577"/>
@@ -702,6 +834,21 @@
             <pc:docMk/>
             <pc:sldMk cId="0" sldId="277"/>
             <ac:spMk id="17" creationId="{13A048EB-EEB4-4AAC-F0EC-0A57623D43CC}"/>
+          </ac:spMkLst>
+        </pc:spChg>
+      </pc:sldChg>
+      <pc:sldChg chg="modSp mod">
+        <pc:chgData name="Justin Hoffman" userId="40d7c2b8f9dba042" providerId="LiveId" clId="{98AE922D-438C-4FBD-AB6F-EAC5EAC34870}" dt="2026-04-25T18:08:24.777" v="1989" actId="20577"/>
+        <pc:sldMkLst>
+          <pc:docMk/>
+          <pc:sldMk cId="0" sldId="278"/>
+        </pc:sldMkLst>
+        <pc:spChg chg="mod">
+          <ac:chgData name="Justin Hoffman" userId="40d7c2b8f9dba042" providerId="LiveId" clId="{98AE922D-438C-4FBD-AB6F-EAC5EAC34870}" dt="2026-04-25T18:08:24.777" v="1989" actId="20577"/>
+          <ac:spMkLst>
+            <pc:docMk/>
+            <pc:sldMk cId="0" sldId="278"/>
+            <ac:spMk id="14" creationId="{BDBAD0DE-0E86-ADCA-291A-353AF0A62265}"/>
           </ac:spMkLst>
         </pc:spChg>
       </pc:sldChg>
@@ -1323,7 +1470,7 @@
                 <a:ea typeface="Calibri" pitchFamily="34" charset="-122"/>
                 <a:cs typeface="Calibri" pitchFamily="34" charset="-120"/>
               </a:rPr>
-              <a:t>9.11x</a:t>
+              <a:t>8.41x</a:t>
             </a:r>
             <a:endParaRPr lang="en-US" sz="2800" dirty="0"/>
           </a:p>
@@ -2211,7 +2358,7 @@
                 <a:ea typeface="Calibri" pitchFamily="34" charset="-122"/>
                 <a:cs typeface="Calibri" pitchFamily="34" charset="-120"/>
               </a:rPr>
-              <a:t>MPI Results</a:t>
+              <a:t>MPI Results (Signs of bottleneck)</a:t>
             </a:r>
             <a:endParaRPr lang="en-US" sz="3000" dirty="0"/>
           </a:p>
@@ -2407,7 +2554,7 @@
           <a:bodyPr/>
           <a:lstStyle/>
           <a:p>
-            <a:endParaRPr lang="en-US"/>
+            <a:endParaRPr lang="en-US" dirty="0"/>
           </a:p>
         </p:txBody>
       </p:sp>
@@ -2444,7 +2591,7 @@
                 <a:ea typeface="Calibri" pitchFamily="34" charset="-122"/>
                 <a:cs typeface="Calibri" pitchFamily="34" charset="-120"/>
               </a:rPr>
-              <a:t>Hybrid Results</a:t>
+              <a:t>Hybrid Results (Expanse thread bottleneck)</a:t>
             </a:r>
             <a:endParaRPr lang="en-US" sz="3000" dirty="0"/>
           </a:p>
@@ -2528,7 +2675,7 @@
                 <a:ea typeface="Calibri" pitchFamily="34" charset="-122"/>
                 <a:cs typeface="Calibri" pitchFamily="34" charset="-120"/>
               </a:rPr>
-              <a:t>Reaches 6.18x at 8p x 16t. The 16p x 16t corner collapses to 0.59x due to overhead.
+              <a:t>Reaches 6.18x at 8p x 16t. Little scaling as at 16p 1t or 1p 16t
 </a:t>
             </a:r>
             <a:r>
@@ -2551,7 +2698,7 @@
                 <a:ea typeface="Calibri" pitchFamily="34" charset="-122"/>
                 <a:cs typeface="Calibri" pitchFamily="34" charset="-120"/>
               </a:rPr>
-              <a:t>Peaks at 2.9x at 1p x 8t. Adding more processes hurts.</a:t>
+              <a:t>Peaks at 2.9x at 1p x 8t. However, is scaling by thread.</a:t>
             </a:r>
             <a:endParaRPr lang="en-US" sz="1600" dirty="0"/>
           </a:p>
@@ -3143,7 +3290,7 @@
                 <a:ea typeface="Calibri" pitchFamily="34" charset="-122"/>
                 <a:cs typeface="Calibri" pitchFamily="34" charset="-120"/>
               </a:rPr>
-              <a:t>Identifying the Bottleneck</a:t>
+              <a:t>Identifying the Bottlenecks</a:t>
             </a:r>
             <a:endParaRPr lang="en-US" sz="3000" dirty="0"/>
           </a:p>
@@ -3351,7 +3498,7 @@
                 <a:ea typeface="Calibri" pitchFamily="34" charset="-122"/>
                 <a:cs typeface="Calibri" pitchFamily="34" charset="-120"/>
               </a:rPr>
-              <a:t>OMP is unaffected</a:t>
+              <a:t>Hybrid threads bound on Expanse</a:t>
             </a:r>
             <a:r>
               <a:rPr lang="en-US" sz="1400" dirty="0">
@@ -3362,9 +3509,16 @@
                 <a:ea typeface="Calibri" pitchFamily="34" charset="-122"/>
                 <a:cs typeface="Calibri" pitchFamily="34" charset="-120"/>
               </a:rPr>
-              <a:t>  copy_rows uses memcpy within shared memory, no broadcast needed</a:t>
-            </a:r>
-            <a:endParaRPr lang="en-US" sz="1400" dirty="0"/>
+              <a:t> due to </a:t>
+            </a:r>
+            <a:r>
+              <a:rPr lang="en-US" sz="1400" dirty="0">
+                <a:solidFill>
+                  <a:srgbClr val="444444"/>
+                </a:solidFill>
+              </a:rPr>
+              <a:t>--map-by and --bind-to core flags, this prevented scaling</a:t>
+            </a:r>
           </a:p>
         </p:txBody>
       </p:sp>
@@ -3714,7 +3868,29 @@
                 <a:ea typeface="Courier New" pitchFamily="34" charset="-122"/>
                 <a:cs typeface="Courier New" pitchFamily="34" charset="-120"/>
               </a:rPr>
-              <a:t>// inside cross_validate — per fold:
+              <a:t>// inside </a:t>
+            </a:r>
+            <a:r>
+              <a:rPr lang="en-US" sz="1050" dirty="0" err="1">
+                <a:solidFill>
+                  <a:srgbClr val="888888"/>
+                </a:solidFill>
+                <a:latin typeface="Courier New" pitchFamily="34" charset="0"/>
+                <a:ea typeface="Courier New" pitchFamily="34" charset="-122"/>
+                <a:cs typeface="Courier New" pitchFamily="34" charset="-120"/>
+              </a:rPr>
+              <a:t>cross_validate</a:t>
+            </a:r>
+            <a:r>
+              <a:rPr lang="en-US" sz="1050" dirty="0">
+                <a:solidFill>
+                  <a:srgbClr val="888888"/>
+                </a:solidFill>
+                <a:latin typeface="Courier New" pitchFamily="34" charset="0"/>
+                <a:ea typeface="Courier New" pitchFamily="34" charset="-122"/>
+                <a:cs typeface="Courier New" pitchFamily="34" charset="-120"/>
+              </a:rPr>
+              <a:t> per fold:
 </a:t>
             </a:r>
             <a:r>
@@ -4052,51 +4228,6 @@
                 <a:ea typeface="Calibri" pitchFamily="34" charset="-122"/>
                 <a:cs typeface="Calibri" pitchFamily="34" charset="-120"/>
               </a:rPr>
-              <a:t>train_model</a:t>
-            </a:r>
-            <a:r>
-              <a:rPr lang="en-US" sz="1400" dirty="0">
-                <a:solidFill>
-                  <a:srgbClr val="444444"/>
-                </a:solidFill>
-                <a:latin typeface="Calibri" pitchFamily="34" charset="0"/>
-                <a:ea typeface="Calibri" pitchFamily="34" charset="-122"/>
-                <a:cs typeface="Calibri" pitchFamily="34" charset="-120"/>
-              </a:rPr>
-              <a:t>  passes NULL for </a:t>
-            </a:r>
-            <a:r>
-              <a:rPr lang="en-US" sz="1400" dirty="0" err="1">
-                <a:solidFill>
-                  <a:srgbClr val="444444"/>
-                </a:solidFill>
-                <a:latin typeface="Calibri" pitchFamily="34" charset="0"/>
-                <a:ea typeface="Calibri" pitchFamily="34" charset="-122"/>
-                <a:cs typeface="Calibri" pitchFamily="34" charset="-120"/>
-              </a:rPr>
-              <a:t>row_indices</a:t>
-            </a:r>
-            <a:r>
-              <a:rPr lang="en-US" sz="1400" dirty="0">
-                <a:solidFill>
-                  <a:srgbClr val="444444"/>
-                </a:solidFill>
-                <a:latin typeface="Calibri" pitchFamily="34" charset="0"/>
-                <a:ea typeface="Calibri" pitchFamily="34" charset="-122"/>
-                <a:cs typeface="Calibri" pitchFamily="34" charset="-120"/>
-              </a:rPr>
-              <a:t>
-</a:t>
-            </a:r>
-            <a:r>
-              <a:rPr lang="en-US" sz="1400" b="1" dirty="0" err="1">
-                <a:solidFill>
-                  <a:srgbClr val="0D3B6E"/>
-                </a:solidFill>
-                <a:latin typeface="Calibri" pitchFamily="34" charset="0"/>
-                <a:ea typeface="Calibri" pitchFamily="34" charset="-122"/>
-                <a:cs typeface="Calibri" pitchFamily="34" charset="-120"/>
-              </a:rPr>
               <a:t>cross_validate</a:t>
             </a:r>
             <a:r>
@@ -4112,6 +4243,17 @@
 </a:t>
             </a:r>
             <a:r>
+              <a:rPr lang="en-US" sz="1400" b="1" dirty="0" err="1">
+                <a:solidFill>
+                  <a:srgbClr val="0D3B6E"/>
+                </a:solidFill>
+                <a:latin typeface="Calibri" pitchFamily="34" charset="0"/>
+                <a:ea typeface="Calibri" pitchFamily="34" charset="-122"/>
+                <a:cs typeface="Calibri" pitchFamily="34" charset="-120"/>
+              </a:rPr>
+              <a:t>sbash</a:t>
+            </a:r>
+            <a:r>
               <a:rPr lang="en-US" sz="1400" b="1" dirty="0">
                 <a:solidFill>
                   <a:srgbClr val="0D3B6E"/>
@@ -4120,7 +4262,7 @@
                 <a:ea typeface="Calibri" pitchFamily="34" charset="-122"/>
                 <a:cs typeface="Calibri" pitchFamily="34" charset="-120"/>
               </a:rPr>
-              <a:t>main</a:t>
+              <a:t> </a:t>
             </a:r>
             <a:r>
               <a:rPr lang="en-US" sz="1400" dirty="0">
@@ -4131,9 +4273,32 @@
                 <a:ea typeface="Calibri" pitchFamily="34" charset="-122"/>
                 <a:cs typeface="Calibri" pitchFamily="34" charset="-120"/>
               </a:rPr>
-              <a:t> all call sites pass NULL for train/classify passes</a:t>
-            </a:r>
-            <a:endParaRPr lang="en-US" sz="1400" dirty="0"/>
+              <a:t>removed map and bind flags and included </a:t>
+            </a:r>
+            <a:r>
+              <a:rPr lang="en-US" sz="1400" dirty="0">
+                <a:solidFill>
+                  <a:srgbClr val="444444"/>
+                </a:solidFill>
+              </a:rPr>
+              <a:t>--bind-to none on every hybrid </a:t>
+            </a:r>
+            <a:r>
+              <a:rPr lang="en-US" sz="1400" dirty="0" err="1">
+                <a:solidFill>
+                  <a:srgbClr val="444444"/>
+                </a:solidFill>
+              </a:rPr>
+              <a:t>mpiexec</a:t>
+            </a:r>
+            <a:r>
+              <a:rPr lang="en-US" sz="1400" dirty="0">
+                <a:solidFill>
+                  <a:srgbClr val="444444"/>
+                </a:solidFill>
+              </a:rPr>
+              <a:t> call</a:t>
+            </a:r>
           </a:p>
         </p:txBody>
       </p:sp>
@@ -4215,7 +4380,7 @@
                 <a:ea typeface="Calibri" pitchFamily="34" charset="-122"/>
                 <a:cs typeface="Calibri" pitchFamily="34" charset="-120"/>
               </a:rPr>
-              <a:t>10 full-dataset broadcasts per CV run eliminated. Each rank builds fold splits locally.</a:t>
+              <a:t>10 full-dataset broadcasts per CV run eliminated. Hybrid and MPI scale properly.</a:t>
             </a:r>
             <a:endParaRPr lang="en-US" sz="1400" dirty="0"/>
           </a:p>
@@ -4467,7 +4632,7 @@
                 <a:ea typeface="Courier New" pitchFamily="34" charset="-122"/>
                 <a:cs typeface="Courier New" pitchFamily="34" charset="-120"/>
               </a:rPr>
-              <a:t>  // pass directly — no copy, no broadcast
+              <a:t>  // pass indices, no copy, no broadcast
 </a:t>
             </a:r>
             <a:r>
@@ -7182,7 +7347,7 @@
             </a:r>
             <a:r>
               <a:rPr lang="en-US" sz="1400" dirty="0"/>
-              <a:t> — File I/O Reference.</a:t>
+              <a:t>, File I/O Reference.</a:t>
             </a:r>
           </a:p>
           <a:p>
@@ -9543,7 +9708,7 @@
         </p:nvSpPr>
         <p:spPr>
           <a:xfrm>
-            <a:off x="4754880" y="2212848"/>
+            <a:off x="4745736" y="2112264"/>
             <a:ext cx="4114800" cy="2743200"/>
           </a:xfrm>
           <a:prstGeom prst="rect">
@@ -9563,18 +9728,14 @@
               <a:buSzPct val="100000"/>
               <a:buChar char="•"/>
             </a:pPr>
-            <a:r>
-              <a:rPr lang="en-US" sz="1600" dirty="0">
-                <a:solidFill>
-                  <a:srgbClr val="1A1A1A"/>
-                </a:solidFill>
-                <a:latin typeface="Calibri" pitchFamily="34" charset="0"/>
-                <a:ea typeface="Calibri" pitchFamily="34" charset="-122"/>
-                <a:cs typeface="Calibri" pitchFamily="34" charset="-120"/>
-              </a:rPr>
-              <a:t>Explicit row range: any partition scheme without code changes</a:t>
-            </a:r>
-            <a:endParaRPr lang="en-US" sz="1600" dirty="0"/>
+            <a:endParaRPr lang="en-US" sz="1600" dirty="0">
+              <a:solidFill>
+                <a:srgbClr val="1A1A1A"/>
+              </a:solidFill>
+              <a:latin typeface="Calibri" pitchFamily="34" charset="0"/>
+              <a:ea typeface="Calibri" pitchFamily="34" charset="-122"/>
+              <a:cs typeface="Calibri" pitchFamily="34" charset="-120"/>
+            </a:endParaRPr>
           </a:p>
           <a:p>
             <a:pPr marL="342900" indent="-342900">
@@ -9593,9 +9754,8 @@
                 <a:ea typeface="Calibri" pitchFamily="34" charset="-122"/>
                 <a:cs typeface="Calibri" pitchFamily="34" charset="-120"/>
               </a:rPr>
-              <a:t>Flat 1D probability array: cache-friendly and trivially reducible</a:t>
-            </a:r>
-            <a:endParaRPr lang="en-US" sz="1600" dirty="0"/>
+              <a:t>Rows are stored in flat 1D arrays for simple row-based access.</a:t>
+            </a:r>
           </a:p>
           <a:p>
             <a:pPr marL="342900" indent="-342900">
@@ -9614,9 +9774,8 @@
                 <a:ea typeface="Calibri" pitchFamily="34" charset="-122"/>
                 <a:cs typeface="Calibri" pitchFamily="34" charset="-120"/>
               </a:rPr>
-              <a:t>log_probs is read-only during classification: zero contention</a:t>
-            </a:r>
-            <a:endParaRPr lang="en-US" sz="1600" dirty="0"/>
+              <a:t>Each row can be trained or classified independently.</a:t>
+            </a:r>
           </a:p>
           <a:p>
             <a:pPr marL="342900" indent="-342900">
@@ -9635,7 +9794,47 @@
                 <a:ea typeface="Calibri" pitchFamily="34" charset="-122"/>
                 <a:cs typeface="Calibri" pitchFamily="34" charset="-120"/>
               </a:rPr>
-              <a:t>All three phases timed independently with omp_get_wtime()</a:t>
+              <a:t>Feature counts are flattened into one shared count array.</a:t>
+            </a:r>
+          </a:p>
+          <a:p>
+            <a:pPr marL="342900" indent="-342900">
+              <a:spcAft>
+                <a:spcPts val="500"/>
+              </a:spcAft>
+              <a:buSzPct val="100000"/>
+              <a:buChar char="•"/>
+            </a:pPr>
+            <a:r>
+              <a:rPr lang="en-US" sz="1600" dirty="0">
+                <a:solidFill>
+                  <a:srgbClr val="1A1A1A"/>
+                </a:solidFill>
+                <a:latin typeface="Calibri" pitchFamily="34" charset="0"/>
+                <a:ea typeface="Calibri" pitchFamily="34" charset="-122"/>
+                <a:cs typeface="Calibri" pitchFamily="34" charset="-120"/>
+              </a:rPr>
+              <a:t>Offsets map each feature/class/value combination to one index.</a:t>
+            </a:r>
+          </a:p>
+          <a:p>
+            <a:pPr marL="342900" indent="-342900">
+              <a:spcAft>
+                <a:spcPts val="500"/>
+              </a:spcAft>
+              <a:buSzPct val="100000"/>
+              <a:buChar char="•"/>
+            </a:pPr>
+            <a:r>
+              <a:rPr lang="en-US" sz="1600" dirty="0">
+                <a:solidFill>
+                  <a:srgbClr val="1A1A1A"/>
+                </a:solidFill>
+                <a:latin typeface="Calibri" pitchFamily="34" charset="0"/>
+                <a:ea typeface="Calibri" pitchFamily="34" charset="-122"/>
+                <a:cs typeface="Calibri" pitchFamily="34" charset="-120"/>
+              </a:rPr>
+              <a:t>Train, classify, and cross-validation can be timed separately.</a:t>
             </a:r>
             <a:endParaRPr lang="en-US" sz="1600" dirty="0"/>
           </a:p>
@@ -11873,17 +12072,69 @@
               <a:t>Rank 0</a:t>
             </a:r>
             <a:r>
+              <a:rPr lang="en-US" sz="1400" b="1" dirty="0">
+                <a:solidFill>
+                  <a:srgbClr val="444444"/>
+                </a:solidFill>
+                <a:latin typeface="Calibri" pitchFamily="34" charset="0"/>
+                <a:ea typeface="Calibri" pitchFamily="34" charset="-122"/>
+                <a:cs typeface="Calibri" pitchFamily="34" charset="-120"/>
+              </a:rPr>
+              <a:t> </a:t>
+            </a:r>
+            <a:r>
+              <a:rPr lang="en-US" sz="1400" b="1" dirty="0">
+                <a:solidFill>
+                  <a:srgbClr val="0D3B6E"/>
+                </a:solidFill>
+                <a:latin typeface="Calibri" pitchFamily="34" charset="0"/>
+                <a:ea typeface="Calibri" pitchFamily="34" charset="-122"/>
+                <a:cs typeface="Calibri" pitchFamily="34" charset="-120"/>
+              </a:rPr>
+              <a:t>reads all data</a:t>
+            </a:r>
+            <a:r>
               <a:rPr lang="en-US" sz="1400" dirty="0">
                 <a:solidFill>
+                  <a:srgbClr val="0D3B6E"/>
+                </a:solidFill>
+                <a:latin typeface="Calibri" pitchFamily="34" charset="0"/>
+                <a:ea typeface="Calibri" pitchFamily="34" charset="-122"/>
+                <a:cs typeface="Calibri" pitchFamily="34" charset="-120"/>
+              </a:rPr>
+              <a:t> </a:t>
+            </a:r>
+            <a:r>
+              <a:rPr lang="en-US" sz="1400" dirty="0" err="1">
+                <a:solidFill>
                   <a:srgbClr val="444444"/>
                 </a:solidFill>
                 <a:latin typeface="Calibri" pitchFamily="34" charset="0"/>
                 <a:ea typeface="Calibri" pitchFamily="34" charset="-122"/>
                 <a:cs typeface="Calibri" pitchFamily="34" charset="-120"/>
               </a:rPr>
-              <a:t>  reads all data, broadcasts full dataset via MPI_Bcast
-</a:t>
-            </a:r>
+              <a:t>MPI_Bcast</a:t>
+            </a:r>
+            <a:r>
+              <a:rPr lang="en-US" sz="1400" dirty="0">
+                <a:solidFill>
+                  <a:srgbClr val="444444"/>
+                </a:solidFill>
+                <a:latin typeface="Calibri" pitchFamily="34" charset="0"/>
+                <a:ea typeface="Calibri" pitchFamily="34" charset="-122"/>
+                <a:cs typeface="Calibri" pitchFamily="34" charset="-120"/>
+              </a:rPr>
+              <a:t> distributes to all ranks</a:t>
+            </a:r>
+          </a:p>
+          <a:p>
+            <a:pPr marL="285750" indent="-285750">
+              <a:spcAft>
+                <a:spcPts val="400"/>
+              </a:spcAft>
+              <a:buFont typeface="Arial" panose="020B0604020202020204" pitchFamily="34" charset="0"/>
+              <a:buChar char="•"/>
+            </a:pPr>
             <a:r>
               <a:rPr lang="en-US" sz="1400" b="1" dirty="0" err="1">
                 <a:solidFill>
@@ -11896,6 +12147,17 @@
               <a:t>accumulate_counts_range</a:t>
             </a:r>
             <a:r>
+              <a:rPr lang="en-US" sz="1400" b="1" dirty="0">
+                <a:solidFill>
+                  <a:srgbClr val="0D3B6E"/>
+                </a:solidFill>
+                <a:latin typeface="Calibri" pitchFamily="34" charset="0"/>
+                <a:ea typeface="Calibri" pitchFamily="34" charset="-122"/>
+                <a:cs typeface="Calibri" pitchFamily="34" charset="-120"/>
+              </a:rPr>
+              <a:t> </a:t>
+            </a:r>
+            <a:r>
               <a:rPr lang="en-US" sz="1400" dirty="0">
                 <a:solidFill>
                   <a:srgbClr val="444444"/>
@@ -11904,9 +12166,39 @@
                 <a:ea typeface="Calibri" pitchFamily="34" charset="-122"/>
                 <a:cs typeface="Calibri" pitchFamily="34" charset="-120"/>
               </a:rPr>
-              <a:t>  each rank processes its row slice, MPI_Allreduce sums counts
-</a:t>
-            </a:r>
+              <a:t>local rows, </a:t>
+            </a:r>
+            <a:r>
+              <a:rPr lang="en-US" sz="1400" dirty="0" err="1">
+                <a:solidFill>
+                  <a:srgbClr val="444444"/>
+                </a:solidFill>
+                <a:latin typeface="Calibri" pitchFamily="34" charset="0"/>
+                <a:ea typeface="Calibri" pitchFamily="34" charset="-122"/>
+                <a:cs typeface="Calibri" pitchFamily="34" charset="-120"/>
+              </a:rPr>
+              <a:t>MPI_Allreduce</a:t>
+            </a:r>
+            <a:r>
+              <a:rPr lang="en-US" sz="1400" dirty="0">
+                <a:solidFill>
+                  <a:srgbClr val="444444"/>
+                </a:solidFill>
+                <a:latin typeface="Calibri" pitchFamily="34" charset="0"/>
+                <a:ea typeface="Calibri" pitchFamily="34" charset="-122"/>
+                <a:cs typeface="Calibri" pitchFamily="34" charset="-120"/>
+              </a:rPr>
+              <a:t> sums counts</a:t>
+            </a:r>
+          </a:p>
+          <a:p>
+            <a:pPr marL="285750" indent="-285750">
+              <a:spcAft>
+                <a:spcPts val="400"/>
+              </a:spcAft>
+              <a:buFont typeface="Arial" panose="020B0604020202020204" pitchFamily="34" charset="0"/>
+              <a:buChar char="•"/>
+            </a:pPr>
             <a:r>
               <a:rPr lang="en-US" sz="1400" b="1" dirty="0" err="1">
                 <a:solidFill>
@@ -11919,6 +12211,17 @@
               <a:t>classify_dataset</a:t>
             </a:r>
             <a:r>
+              <a:rPr lang="en-US" sz="1400" b="1" dirty="0">
+                <a:solidFill>
+                  <a:srgbClr val="0D3B6E"/>
+                </a:solidFill>
+                <a:latin typeface="Calibri" pitchFamily="34" charset="0"/>
+                <a:ea typeface="Calibri" pitchFamily="34" charset="-122"/>
+                <a:cs typeface="Calibri" pitchFamily="34" charset="-120"/>
+              </a:rPr>
+              <a:t> </a:t>
+            </a:r>
+            <a:r>
               <a:rPr lang="en-US" sz="1400" dirty="0">
                 <a:solidFill>
                   <a:srgbClr val="444444"/>
@@ -11927,9 +12230,39 @@
                 <a:ea typeface="Calibri" pitchFamily="34" charset="-122"/>
                 <a:cs typeface="Calibri" pitchFamily="34" charset="-120"/>
               </a:rPr>
-              <a:t>  each rank classifies its slice, MPI_Allgatherv assembles predictions
-</a:t>
-            </a:r>
+              <a:t>local rows, </a:t>
+            </a:r>
+            <a:r>
+              <a:rPr lang="en-US" sz="1400" dirty="0" err="1">
+                <a:solidFill>
+                  <a:srgbClr val="444444"/>
+                </a:solidFill>
+                <a:latin typeface="Calibri" pitchFamily="34" charset="0"/>
+                <a:ea typeface="Calibri" pitchFamily="34" charset="-122"/>
+                <a:cs typeface="Calibri" pitchFamily="34" charset="-120"/>
+              </a:rPr>
+              <a:t>MPI_Allgatherv</a:t>
+            </a:r>
+            <a:r>
+              <a:rPr lang="en-US" sz="1400" dirty="0">
+                <a:solidFill>
+                  <a:srgbClr val="444444"/>
+                </a:solidFill>
+                <a:latin typeface="Calibri" pitchFamily="34" charset="0"/>
+                <a:ea typeface="Calibri" pitchFamily="34" charset="-122"/>
+                <a:cs typeface="Calibri" pitchFamily="34" charset="-120"/>
+              </a:rPr>
+              <a:t> collects predictions</a:t>
+            </a:r>
+          </a:p>
+          <a:p>
+            <a:pPr marL="285750" indent="-285750">
+              <a:spcAft>
+                <a:spcPts val="400"/>
+              </a:spcAft>
+              <a:buFont typeface="Arial" panose="020B0604020202020204" pitchFamily="34" charset="0"/>
+              <a:buChar char="•"/>
+            </a:pPr>
             <a:r>
               <a:rPr lang="en-US" sz="1400" b="1" dirty="0" err="1">
                 <a:solidFill>
@@ -11942,6 +12275,17 @@
               <a:t>build_truth</a:t>
             </a:r>
             <a:r>
+              <a:rPr lang="en-US" sz="1400" b="1" dirty="0">
+                <a:solidFill>
+                  <a:srgbClr val="0D3B6E"/>
+                </a:solidFill>
+                <a:latin typeface="Calibri" pitchFamily="34" charset="0"/>
+                <a:ea typeface="Calibri" pitchFamily="34" charset="-122"/>
+                <a:cs typeface="Calibri" pitchFamily="34" charset="-120"/>
+              </a:rPr>
+              <a:t> </a:t>
+            </a:r>
+            <a:r>
               <a:rPr lang="en-US" sz="1400" dirty="0">
                 <a:solidFill>
                   <a:srgbClr val="444444"/>
@@ -11950,9 +12294,39 @@
                 <a:ea typeface="Calibri" pitchFamily="34" charset="-122"/>
                 <a:cs typeface="Calibri" pitchFamily="34" charset="-120"/>
               </a:rPr>
-              <a:t>  each rank extracts its label slice, MPI_Allgatherv reassembles
-</a:t>
-            </a:r>
+              <a:t>local labels, </a:t>
+            </a:r>
+            <a:r>
+              <a:rPr lang="en-US" sz="1400" dirty="0" err="1">
+                <a:solidFill>
+                  <a:srgbClr val="444444"/>
+                </a:solidFill>
+                <a:latin typeface="Calibri" pitchFamily="34" charset="0"/>
+                <a:ea typeface="Calibri" pitchFamily="34" charset="-122"/>
+                <a:cs typeface="Calibri" pitchFamily="34" charset="-120"/>
+              </a:rPr>
+              <a:t>MPI_Allgatherv</a:t>
+            </a:r>
+            <a:r>
+              <a:rPr lang="en-US" sz="1400" dirty="0">
+                <a:solidFill>
+                  <a:srgbClr val="444444"/>
+                </a:solidFill>
+                <a:latin typeface="Calibri" pitchFamily="34" charset="0"/>
+                <a:ea typeface="Calibri" pitchFamily="34" charset="-122"/>
+                <a:cs typeface="Calibri" pitchFamily="34" charset="-120"/>
+              </a:rPr>
+              <a:t> collects truth</a:t>
+            </a:r>
+          </a:p>
+          <a:p>
+            <a:pPr marL="285750" indent="-285750">
+              <a:spcAft>
+                <a:spcPts val="400"/>
+              </a:spcAft>
+              <a:buFont typeface="Arial" panose="020B0604020202020204" pitchFamily="34" charset="0"/>
+              <a:buChar char="•"/>
+            </a:pPr>
             <a:r>
               <a:rPr lang="en-US" sz="1400" b="1" dirty="0" err="1">
                 <a:solidFill>
@@ -11965,6 +12339,17 @@
               <a:t>compute_accuracy</a:t>
             </a:r>
             <a:r>
+              <a:rPr lang="en-US" sz="1400" b="1" dirty="0">
+                <a:solidFill>
+                  <a:srgbClr val="0D3B6E"/>
+                </a:solidFill>
+                <a:latin typeface="Calibri" pitchFamily="34" charset="0"/>
+                <a:ea typeface="Calibri" pitchFamily="34" charset="-122"/>
+                <a:cs typeface="Calibri" pitchFamily="34" charset="-120"/>
+              </a:rPr>
+              <a:t> </a:t>
+            </a:r>
+            <a:r>
               <a:rPr lang="en-US" sz="1400" dirty="0">
                 <a:solidFill>
                   <a:srgbClr val="444444"/>
@@ -11973,9 +12358,39 @@
                 <a:ea typeface="Calibri" pitchFamily="34" charset="-122"/>
                 <a:cs typeface="Calibri" pitchFamily="34" charset="-120"/>
               </a:rPr>
-              <a:t>  local correct count summed with MPI_Allreduce
-</a:t>
-            </a:r>
+              <a:t>local counts, </a:t>
+            </a:r>
+            <a:r>
+              <a:rPr lang="en-US" sz="1400" dirty="0" err="1">
+                <a:solidFill>
+                  <a:srgbClr val="444444"/>
+                </a:solidFill>
+                <a:latin typeface="Calibri" pitchFamily="34" charset="0"/>
+                <a:ea typeface="Calibri" pitchFamily="34" charset="-122"/>
+                <a:cs typeface="Calibri" pitchFamily="34" charset="-120"/>
+              </a:rPr>
+              <a:t>MPI_Allreduce</a:t>
+            </a:r>
+            <a:r>
+              <a:rPr lang="en-US" sz="1400" dirty="0">
+                <a:solidFill>
+                  <a:srgbClr val="444444"/>
+                </a:solidFill>
+                <a:latin typeface="Calibri" pitchFamily="34" charset="0"/>
+                <a:ea typeface="Calibri" pitchFamily="34" charset="-122"/>
+                <a:cs typeface="Calibri" pitchFamily="34" charset="-120"/>
+              </a:rPr>
+              <a:t> sums total</a:t>
+            </a:r>
+          </a:p>
+          <a:p>
+            <a:pPr marL="285750" indent="-285750">
+              <a:spcAft>
+                <a:spcPts val="400"/>
+              </a:spcAft>
+              <a:buFont typeface="Arial" panose="020B0604020202020204" pitchFamily="34" charset="0"/>
+              <a:buChar char="•"/>
+            </a:pPr>
             <a:r>
               <a:rPr lang="en-US" sz="1400" b="1" dirty="0" err="1">
                 <a:solidFill>
@@ -11988,6 +12403,17 @@
               <a:t>copy_rows</a:t>
             </a:r>
             <a:r>
+              <a:rPr lang="en-US" sz="1400" b="1" dirty="0">
+                <a:solidFill>
+                  <a:srgbClr val="0D3B6E"/>
+                </a:solidFill>
+                <a:latin typeface="Calibri" pitchFamily="34" charset="0"/>
+                <a:ea typeface="Calibri" pitchFamily="34" charset="-122"/>
+                <a:cs typeface="Calibri" pitchFamily="34" charset="-120"/>
+              </a:rPr>
+              <a:t> </a:t>
+            </a:r>
+            <a:r>
               <a:rPr lang="en-US" sz="1400" dirty="0">
                 <a:solidFill>
                   <a:srgbClr val="444444"/>
@@ -11996,9 +12422,39 @@
                 <a:ea typeface="Calibri" pitchFamily="34" charset="-122"/>
                 <a:cs typeface="Calibri" pitchFamily="34" charset="-120"/>
               </a:rPr>
-              <a:t>  each rank copies its slice, MPI_Allgatherv reassembles full split
-</a:t>
-            </a:r>
+              <a:t>local split, </a:t>
+            </a:r>
+            <a:r>
+              <a:rPr lang="en-US" sz="1400" dirty="0" err="1">
+                <a:solidFill>
+                  <a:srgbClr val="444444"/>
+                </a:solidFill>
+                <a:latin typeface="Calibri" pitchFamily="34" charset="0"/>
+                <a:ea typeface="Calibri" pitchFamily="34" charset="-122"/>
+                <a:cs typeface="Calibri" pitchFamily="34" charset="-120"/>
+              </a:rPr>
+              <a:t>MPI_Allgatherv</a:t>
+            </a:r>
+            <a:r>
+              <a:rPr lang="en-US" sz="1400" dirty="0">
+                <a:solidFill>
+                  <a:srgbClr val="444444"/>
+                </a:solidFill>
+                <a:latin typeface="Calibri" pitchFamily="34" charset="0"/>
+                <a:ea typeface="Calibri" pitchFamily="34" charset="-122"/>
+                <a:cs typeface="Calibri" pitchFamily="34" charset="-120"/>
+              </a:rPr>
+              <a:t> rebuilds full dataset</a:t>
+            </a:r>
+          </a:p>
+          <a:p>
+            <a:pPr marL="285750" indent="-285750">
+              <a:spcAft>
+                <a:spcPts val="400"/>
+              </a:spcAft>
+              <a:buFont typeface="Arial" panose="020B0604020202020204" pitchFamily="34" charset="0"/>
+              <a:buChar char="•"/>
+            </a:pPr>
             <a:r>
               <a:rPr lang="en-US" sz="1400" b="1" dirty="0" err="1">
                 <a:solidFill>
@@ -12011,6 +12467,17 @@
               <a:t>confusion_matrix_binary</a:t>
             </a:r>
             <a:r>
+              <a:rPr lang="en-US" sz="1400" b="1" dirty="0">
+                <a:solidFill>
+                  <a:srgbClr val="0D3B6E"/>
+                </a:solidFill>
+                <a:latin typeface="Calibri" pitchFamily="34" charset="0"/>
+                <a:ea typeface="Calibri" pitchFamily="34" charset="-122"/>
+                <a:cs typeface="Calibri" pitchFamily="34" charset="-120"/>
+              </a:rPr>
+              <a:t> </a:t>
+            </a:r>
+            <a:r>
               <a:rPr lang="en-US" sz="1400" dirty="0">
                 <a:solidFill>
                   <a:srgbClr val="444444"/>
@@ -12019,7 +12486,29 @@
                 <a:ea typeface="Calibri" pitchFamily="34" charset="-122"/>
                 <a:cs typeface="Calibri" pitchFamily="34" charset="-120"/>
               </a:rPr>
-              <a:t>  local TN/FP/FN/TP counts reduced to rank 0 with MPI_Reduce</a:t>
+              <a:t>local TN/FP/FN/TP, </a:t>
+            </a:r>
+            <a:r>
+              <a:rPr lang="en-US" sz="1400" dirty="0" err="1">
+                <a:solidFill>
+                  <a:srgbClr val="444444"/>
+                </a:solidFill>
+                <a:latin typeface="Calibri" pitchFamily="34" charset="0"/>
+                <a:ea typeface="Calibri" pitchFamily="34" charset="-122"/>
+                <a:cs typeface="Calibri" pitchFamily="34" charset="-120"/>
+              </a:rPr>
+              <a:t>MPI_Reduce</a:t>
+            </a:r>
+            <a:r>
+              <a:rPr lang="en-US" sz="1400" dirty="0">
+                <a:solidFill>
+                  <a:srgbClr val="444444"/>
+                </a:solidFill>
+                <a:latin typeface="Calibri" pitchFamily="34" charset="0"/>
+                <a:ea typeface="Calibri" pitchFamily="34" charset="-122"/>
+                <a:cs typeface="Calibri" pitchFamily="34" charset="-120"/>
+              </a:rPr>
+              <a:t> to rank 0</a:t>
             </a:r>
             <a:endParaRPr lang="en-US" sz="1400" dirty="0"/>
           </a:p>
@@ -12088,6 +12577,17 @@
             <a:pPr marL="0" indent="0">
               <a:buNone/>
             </a:pPr>
+            <a:r>
+              <a:rPr lang="en-US" sz="1400" i="1" dirty="0">
+                <a:solidFill>
+                  <a:srgbClr val="888888"/>
+                </a:solidFill>
+                <a:latin typeface="Calibri" pitchFamily="34" charset="0"/>
+                <a:ea typeface="Calibri" pitchFamily="34" charset="-122"/>
+                <a:cs typeface="Calibri" pitchFamily="34" charset="-120"/>
+              </a:rPr>
+              <a:t>Function: </a:t>
+            </a:r>
             <a:r>
               <a:rPr lang="en-US" sz="1400" i="1" dirty="0" err="1">
                 <a:solidFill>
@@ -12303,6 +12803,17 @@
             <a:pPr marL="0" indent="0">
               <a:buNone/>
             </a:pPr>
+            <a:r>
+              <a:rPr lang="en-US" sz="1400" i="1" dirty="0">
+                <a:solidFill>
+                  <a:srgbClr val="888888"/>
+                </a:solidFill>
+                <a:latin typeface="Calibri" pitchFamily="34" charset="0"/>
+                <a:ea typeface="Calibri" pitchFamily="34" charset="-122"/>
+                <a:cs typeface="Calibri" pitchFamily="34" charset="-120"/>
+              </a:rPr>
+              <a:t>Function: </a:t>
+            </a:r>
             <a:r>
               <a:rPr lang="en-US" sz="1400" i="1" dirty="0" err="1">
                 <a:solidFill>

</xml_diff>